<commit_message>
Complete verified step visuals and guides for Lab 09
</commit_message>
<xml_diff>
--- a/slides/LAB09_Gradio_Sentiment_Bukti_Live.pptx
+++ b/slides/LAB09_Gradio_Sentiment_Bukti_Live.pptx
@@ -21,6 +21,7 @@
     <p:sldId id="298" r:id="rId12"/>
     <p:sldId id="299" r:id="rId13"/>
     <p:sldId id="300" r:id="rId14"/>
+    <p:sldId id="301" r:id="rId20"/>
   </p:sldIdLst>
   <p:sldSz cx="12192000" cy="6858000"/>
   <p:notesSz cx="6858000" cy="9144000"/>
@@ -1932,6 +1933,10 @@
             <a:prstDash val="solid"/>
           </a:ln>
         </p:spPr>
+        <p:txBody>
+          <a:bodyPr/>
+          <a:p/>
+        </p:txBody>
       </p:sp>
       <p:sp>
         <p:nvSpPr>
@@ -2233,6 +2238,10 @@
             <a:prstDash val="solid"/>
           </a:ln>
         </p:spPr>
+        <p:txBody>
+          <a:bodyPr/>
+          <a:p/>
+        </p:txBody>
       </p:sp>
       <p:pic>
         <p:nvPicPr>
@@ -2312,6 +2321,10 @@
             <a:prstDash val="solid"/>
           </a:ln>
         </p:spPr>
+        <p:txBody>
+          <a:bodyPr/>
+          <a:p/>
+        </p:txBody>
       </p:sp>
       <p:sp>
         <p:nvSpPr>
@@ -2437,6 +2450,10 @@
             <a:prstDash val="solid"/>
           </a:ln>
         </p:spPr>
+        <p:txBody>
+          <a:bodyPr/>
+          <a:p/>
+        </p:txBody>
       </p:sp>
       <p:sp>
         <p:nvSpPr>
@@ -2470,6 +2487,10 @@
             <a:prstDash val="solid"/>
           </a:ln>
         </p:spPr>
+        <p:txBody>
+          <a:bodyPr/>
+          <a:p/>
+        </p:txBody>
       </p:sp>
       <p:sp>
         <p:nvSpPr>
@@ -2503,6 +2524,10 @@
             <a:prstDash val="solid"/>
           </a:ln>
         </p:spPr>
+        <p:txBody>
+          <a:bodyPr/>
+          <a:p/>
+        </p:txBody>
       </p:sp>
       <p:sp>
         <p:nvSpPr>
@@ -2536,6 +2561,10 @@
             <a:prstDash val="solid"/>
           </a:ln>
         </p:spPr>
+        <p:txBody>
+          <a:bodyPr/>
+          <a:p/>
+        </p:txBody>
       </p:sp>
       <p:sp>
         <p:nvSpPr>
@@ -2569,6 +2598,10 @@
             <a:prstDash val="solid"/>
           </a:ln>
         </p:spPr>
+        <p:txBody>
+          <a:bodyPr/>
+          <a:p/>
+        </p:txBody>
       </p:sp>
       <p:sp>
         <p:nvSpPr>
@@ -2715,6 +2748,10 @@
             <a:prstDash val="solid"/>
           </a:ln>
         </p:spPr>
+        <p:txBody>
+          <a:bodyPr/>
+          <a:p/>
+        </p:txBody>
       </p:sp>
       <p:sp>
         <p:nvSpPr>
@@ -2748,6 +2785,10 @@
             <a:prstDash val="solid"/>
           </a:ln>
         </p:spPr>
+        <p:txBody>
+          <a:bodyPr/>
+          <a:p/>
+        </p:txBody>
       </p:sp>
       <p:sp>
         <p:nvSpPr>
@@ -2781,6 +2822,10 @@
             <a:prstDash val="solid"/>
           </a:ln>
         </p:spPr>
+        <p:txBody>
+          <a:bodyPr/>
+          <a:p/>
+        </p:txBody>
       </p:sp>
       <p:sp>
         <p:nvSpPr>
@@ -2814,6 +2859,10 @@
             <a:prstDash val="solid"/>
           </a:ln>
         </p:spPr>
+        <p:txBody>
+          <a:bodyPr/>
+          <a:p/>
+        </p:txBody>
       </p:sp>
       <p:sp>
         <p:nvSpPr>
@@ -2847,6 +2896,10 @@
             <a:prstDash val="solid"/>
           </a:ln>
         </p:spPr>
+        <p:txBody>
+          <a:bodyPr/>
+          <a:p/>
+        </p:txBody>
       </p:sp>
       <p:sp>
         <p:nvSpPr>
@@ -3127,6 +3180,10 @@
             <a:prstDash val="solid"/>
           </a:ln>
         </p:spPr>
+        <p:txBody>
+          <a:bodyPr/>
+          <a:p/>
+        </p:txBody>
       </p:sp>
       <p:pic>
         <p:nvPicPr>
@@ -3206,6 +3263,10 @@
             <a:prstDash val="solid"/>
           </a:ln>
         </p:spPr>
+        <p:txBody>
+          <a:bodyPr/>
+          <a:p/>
+        </p:txBody>
       </p:sp>
       <p:sp>
         <p:nvSpPr>
@@ -3331,6 +3392,10 @@
             <a:prstDash val="solid"/>
           </a:ln>
         </p:spPr>
+        <p:txBody>
+          <a:bodyPr/>
+          <a:p/>
+        </p:txBody>
       </p:sp>
       <p:sp>
         <p:nvSpPr>
@@ -3935,6 +4000,10 @@
             <a:prstDash val="solid"/>
           </a:ln>
         </p:spPr>
+        <p:txBody>
+          <a:bodyPr/>
+          <a:p/>
+        </p:txBody>
       </p:sp>
       <p:sp>
         <p:nvSpPr>
@@ -4052,6 +4121,10 @@
             <a:prstDash val="solid"/>
           </a:ln>
         </p:spPr>
+        <p:txBody>
+          <a:bodyPr/>
+          <a:p/>
+        </p:txBody>
       </p:sp>
       <p:sp>
         <p:nvSpPr>
@@ -4302,6 +4375,10 @@
             <a:prstDash val="solid"/>
           </a:ln>
         </p:spPr>
+        <p:txBody>
+          <a:bodyPr/>
+          <a:p/>
+        </p:txBody>
       </p:sp>
       <p:pic>
         <p:nvPicPr>
@@ -4381,6 +4458,10 @@
             <a:prstDash val="solid"/>
           </a:ln>
         </p:spPr>
+        <p:txBody>
+          <a:bodyPr/>
+          <a:p/>
+        </p:txBody>
       </p:sp>
       <p:sp>
         <p:nvSpPr>
@@ -4506,6 +4587,10 @@
             <a:prstDash val="solid"/>
           </a:ln>
         </p:spPr>
+        <p:txBody>
+          <a:bodyPr/>
+          <a:p/>
+        </p:txBody>
       </p:sp>
       <p:sp>
         <p:nvSpPr>
@@ -5110,6 +5195,10 @@
             <a:prstDash val="solid"/>
           </a:ln>
         </p:spPr>
+        <p:txBody>
+          <a:bodyPr/>
+          <a:p/>
+        </p:txBody>
       </p:sp>
       <p:sp>
         <p:nvSpPr>
@@ -5227,6 +5316,10 @@
             <a:prstDash val="solid"/>
           </a:ln>
         </p:spPr>
+        <p:txBody>
+          <a:bodyPr/>
+          <a:p/>
+        </p:txBody>
       </p:sp>
       <p:sp>
         <p:nvSpPr>
@@ -5477,6 +5570,10 @@
             <a:prstDash val="solid"/>
           </a:ln>
         </p:spPr>
+        <p:txBody>
+          <a:bodyPr/>
+          <a:p/>
+        </p:txBody>
       </p:sp>
       <p:pic>
         <p:nvPicPr>
@@ -5556,6 +5653,10 @@
             <a:prstDash val="solid"/>
           </a:ln>
         </p:spPr>
+        <p:txBody>
+          <a:bodyPr/>
+          <a:p/>
+        </p:txBody>
       </p:sp>
       <p:sp>
         <p:nvSpPr>
@@ -5681,6 +5782,10 @@
             <a:prstDash val="solid"/>
           </a:ln>
         </p:spPr>
+        <p:txBody>
+          <a:bodyPr/>
+          <a:p/>
+        </p:txBody>
       </p:sp>
       <p:sp>
         <p:nvSpPr>
@@ -5714,6 +5819,10 @@
             <a:prstDash val="solid"/>
           </a:ln>
         </p:spPr>
+        <p:txBody>
+          <a:bodyPr/>
+          <a:p/>
+        </p:txBody>
       </p:sp>
       <p:sp>
         <p:nvSpPr>
@@ -5747,6 +5856,10 @@
             <a:prstDash val="solid"/>
           </a:ln>
         </p:spPr>
+        <p:txBody>
+          <a:bodyPr/>
+          <a:p/>
+        </p:txBody>
       </p:sp>
       <p:sp>
         <p:nvSpPr>
@@ -5780,6 +5893,10 @@
             <a:prstDash val="solid"/>
           </a:ln>
         </p:spPr>
+        <p:txBody>
+          <a:bodyPr/>
+          <a:p/>
+        </p:txBody>
       </p:sp>
       <p:sp>
         <p:nvSpPr>
@@ -5813,6 +5930,10 @@
             <a:prstDash val="solid"/>
           </a:ln>
         </p:spPr>
+        <p:txBody>
+          <a:bodyPr/>
+          <a:p/>
+        </p:txBody>
       </p:sp>
       <p:sp>
         <p:nvSpPr>
@@ -5961,6 +6082,10 @@
             <a:prstDash val="solid"/>
           </a:ln>
         </p:spPr>
+        <p:txBody>
+          <a:bodyPr/>
+          <a:p/>
+        </p:txBody>
       </p:sp>
       <p:sp>
         <p:nvSpPr>
@@ -5994,6 +6119,10 @@
             <a:prstDash val="solid"/>
           </a:ln>
         </p:spPr>
+        <p:txBody>
+          <a:bodyPr/>
+          <a:p/>
+        </p:txBody>
       </p:sp>
       <p:sp>
         <p:nvSpPr>
@@ -6027,6 +6156,10 @@
             <a:prstDash val="solid"/>
           </a:ln>
         </p:spPr>
+        <p:txBody>
+          <a:bodyPr/>
+          <a:p/>
+        </p:txBody>
       </p:sp>
       <p:sp>
         <p:nvSpPr>
@@ -6060,6 +6193,10 @@
             <a:prstDash val="solid"/>
           </a:ln>
         </p:spPr>
+        <p:txBody>
+          <a:bodyPr/>
+          <a:p/>
+        </p:txBody>
       </p:sp>
       <p:sp>
         <p:nvSpPr>
@@ -6093,6 +6230,10 @@
             <a:prstDash val="solid"/>
           </a:ln>
         </p:spPr>
+        <p:txBody>
+          <a:bodyPr/>
+          <a:p/>
+        </p:txBody>
       </p:sp>
       <p:sp>
         <p:nvSpPr>
@@ -6216,6 +6357,1169 @@
         <p14:creationId xmlns:p14="http://schemas.microsoft.com/office/powerpoint/2010/main" val="321330954"/>
       </p:ext>
     </p:extLst>
+  </p:cSld>
+  <p:clrMapOvr>
+    <a:masterClrMapping/>
+  </p:clrMapOvr>
+</p:sld>
+</file>
+
+<file path=ppt/slides/slide14.xml><?xml version="1.0" encoding="utf-8"?>
+<p:sld xmlns:a="http://schemas.openxmlformats.org/drawingml/2006/main" xmlns:p="http://schemas.openxmlformats.org/presentationml/2006/main" xmlns:r="http://schemas.openxmlformats.org/officeDocument/2006/relationships">
+  <p:cSld>
+    <p:spTree>
+      <p:nvGrpSpPr>
+        <p:cNvPr id="1" name=""/>
+        <p:cNvGrpSpPr/>
+        <p:nvPr/>
+      </p:nvGrpSpPr>
+      <p:grpSpPr/>
+      <p:sp>
+        <p:nvSpPr>
+          <p:cNvPr id="2" name="Text 0">
+            <a:extLst>
+              <a:ext uri="{FF2B5EF4-FFF2-40B4-BE49-F238E27FC236}">
+                <a16:creationId xmlns:a16="http://schemas.microsoft.com/office/drawing/2014/main" id="{7AC960A9-602C-4D55-AA17-A15286FA159D}"/>
+              </a:ext>
+            </a:extLst>
+          </p:cNvPr>
+          <p:cNvSpPr>
+            <a:spLocks noGrp="1"/>
+          </p:cNvSpPr>
+          <p:nvPr/>
+        </p:nvSpPr>
+        <p:spPr>
+          <a:xfrm>
+            <a:off x="457200" y="6492240"/>
+            <a:ext cx="7315200" cy="274320"/>
+          </a:xfrm>
+          <a:prstGeom prst="rect">
+            <a:avLst/>
+          </a:prstGeom>
+          <a:noFill/>
+        </p:spPr>
+        <p:txBody>
+          <a:bodyPr wrap="square" lIns="0" tIns="0" rIns="0" bIns="0" anchor="ctr"/>
+          <a:lstStyle/>
+          <a:p>
+            <a:pPr marL="0" indent="0" algn="l">
+              <a:buNone/>
+            </a:pPr>
+            <a:r>
+              <a:rPr sz="900">
+                <a:solidFill>
+                  <a:srgbClr val="64748B"/>
+                </a:solidFill>
+                <a:latin typeface="Calibri"/>
+                <a:ea typeface="Calibri"/>
+                <a:cs typeface="Calibri"/>
+              </a:rPr>
+              <a:t>BINUS UNIVERSITY  |  Cloud Services  |  Praktikum 9</a:t>
+            </a:r>
+            <a:endParaRPr sz="900"/>
+          </a:p>
+        </p:txBody>
+      </p:sp>
+      <p:sp>
+        <p:nvSpPr>
+          <p:cNvPr id="3" name="Text 1">
+            <a:extLst>
+              <a:ext uri="{FF2B5EF4-FFF2-40B4-BE49-F238E27FC236}">
+                <a16:creationId xmlns:a16="http://schemas.microsoft.com/office/drawing/2014/main" id="{C513AED4-2391-47D0-9206-360588FA1D2E}"/>
+              </a:ext>
+            </a:extLst>
+          </p:cNvPr>
+          <p:cNvSpPr>
+            <a:spLocks noGrp="1"/>
+          </p:cNvSpPr>
+          <p:nvPr/>
+        </p:nvSpPr>
+        <p:spPr>
+          <a:xfrm>
+            <a:off x="11247120" y="6492240"/>
+            <a:ext cx="457200" cy="274320"/>
+          </a:xfrm>
+          <a:prstGeom prst="rect">
+            <a:avLst/>
+          </a:prstGeom>
+          <a:noFill/>
+        </p:spPr>
+        <p:txBody>
+          <a:bodyPr wrap="square" lIns="0" tIns="0" rIns="0" bIns="0" anchor="ctr"/>
+          <a:lstStyle/>
+          <a:p>
+            <a:pPr marL="0" indent="0" algn="r">
+              <a:buNone/>
+            </a:pPr>
+            <a:r>
+              <a:rPr lang="en-US" sz="900" b="1">
+                <a:solidFill>
+                  <a:srgbClr val="64748B"/>
+                </a:solidFill>
+                <a:latin typeface="Calibri"/>
+                <a:ea typeface="Calibri"/>
+                <a:cs typeface="Calibri"/>
+              </a:rPr>
+              <a:t>14</a:t>
+            </a:r>
+            <a:endParaRPr sz="900"/>
+          </a:p>
+        </p:txBody>
+      </p:sp>
+      <p:sp>
+        <p:nvSpPr>
+          <p:cNvPr id="4" name="Shape 2">
+            <a:extLst>
+              <a:ext uri="{FF2B5EF4-FFF2-40B4-BE49-F238E27FC236}">
+                <a16:creationId xmlns:a16="http://schemas.microsoft.com/office/drawing/2014/main" id="{30F9DE12-2E19-4B8E-B6B5-229506FE52D6}"/>
+              </a:ext>
+            </a:extLst>
+          </p:cNvPr>
+          <p:cNvSpPr>
+            <a:spLocks noGrp="1"/>
+          </p:cNvSpPr>
+          <p:nvPr/>
+        </p:nvSpPr>
+        <p:spPr>
+          <a:xfrm>
+            <a:off x="457200" y="6446520"/>
+            <a:ext cx="228600" cy="36576"/>
+          </a:xfrm>
+          <a:prstGeom prst="rect">
+            <a:avLst/>
+          </a:prstGeom>
+          <a:solidFill>
+            <a:srgbClr val="F37021"/>
+          </a:solidFill>
+          <a:ln w="12700">
+            <a:solidFill>
+              <a:srgbClr val="F37021"/>
+            </a:solidFill>
+            <a:prstDash val="solid"/>
+          </a:ln>
+        </p:spPr>
+        <p:txBody>
+          <a:bodyPr/>
+          <a:p/>
+        </p:txBody>
+      </p:sp>
+      <p:pic>
+        <p:nvPicPr>
+          <p:cNvPr id="43" name="Image 0"/>
+          <p:cNvPicPr>
+            <a:picLocks noChangeAspect="1"/>
+          </p:cNvPicPr>
+          <p:nvPr/>
+        </p:nvPicPr>
+        <p:blipFill>
+          <a:blip r:embed="rId3"/>
+          <a:stretch>
+            <a:fillRect/>
+          </a:stretch>
+        </p:blipFill>
+        <p:spPr>
+          <a:xfrm>
+            <a:off x="274320" y="164592"/>
+            <a:ext cx="914400" cy="603504"/>
+          </a:xfrm>
+          <a:prstGeom prst="rect">
+            <a:avLst/>
+          </a:prstGeom>
+        </p:spPr>
+      </p:pic>
+      <p:pic>
+        <p:nvPicPr>
+          <p:cNvPr id="44" name="Image 1"/>
+          <p:cNvPicPr>
+            <a:picLocks noChangeAspect="1"/>
+          </p:cNvPicPr>
+          <p:nvPr/>
+        </p:nvPicPr>
+        <p:blipFill>
+          <a:blip r:embed="rId10"/>
+          <a:stretch>
+            <a:fillRect/>
+          </a:stretch>
+        </p:blipFill>
+        <p:spPr>
+          <a:xfrm>
+            <a:off x="10881360" y="182880"/>
+            <a:ext cx="1005840" cy="512064"/>
+          </a:xfrm>
+          <a:prstGeom prst="rect">
+            <a:avLst/>
+          </a:prstGeom>
+        </p:spPr>
+      </p:pic>
+      <p:sp>
+        <p:nvSpPr>
+          <p:cNvPr id="7" name="Shape 3">
+            <a:extLst>
+              <a:ext uri="{FF2B5EF4-FFF2-40B4-BE49-F238E27FC236}">
+                <a16:creationId xmlns:a16="http://schemas.microsoft.com/office/drawing/2014/main" id="{B6AD358F-20C5-4F56-A575-6AF86DBE353F}"/>
+              </a:ext>
+            </a:extLst>
+          </p:cNvPr>
+          <p:cNvSpPr>
+            <a:spLocks noGrp="1"/>
+          </p:cNvSpPr>
+          <p:nvPr/>
+        </p:nvSpPr>
+        <p:spPr>
+          <a:xfrm>
+            <a:off x="457200" y="868680"/>
+            <a:ext cx="11247120" cy="0"/>
+          </a:xfrm>
+          <a:prstGeom prst="line">
+            <a:avLst/>
+          </a:prstGeom>
+          <a:noFill/>
+          <a:ln w="12700">
+            <a:solidFill>
+              <a:srgbClr val="E2E8F0"/>
+            </a:solidFill>
+            <a:prstDash val="solid"/>
+          </a:ln>
+        </p:spPr>
+        <p:txBody>
+          <a:bodyPr/>
+          <a:p/>
+        </p:txBody>
+      </p:sp>
+      <p:sp>
+        <p:nvSpPr>
+          <p:cNvPr id="8" name="Text 4">
+            <a:extLst>
+              <a:ext uri="{FF2B5EF4-FFF2-40B4-BE49-F238E27FC236}">
+                <a16:creationId xmlns:a16="http://schemas.microsoft.com/office/drawing/2014/main" id="{44FF1BE9-F166-485A-9C24-CA72E1679E38}"/>
+              </a:ext>
+            </a:extLst>
+          </p:cNvPr>
+          <p:cNvSpPr>
+            <a:spLocks noGrp="1"/>
+          </p:cNvSpPr>
+          <p:nvPr/>
+        </p:nvSpPr>
+        <p:spPr>
+          <a:xfrm>
+            <a:off x="2011680" y="182880"/>
+            <a:ext cx="8138160" cy="502920"/>
+          </a:xfrm>
+          <a:prstGeom prst="rect">
+            <a:avLst/>
+          </a:prstGeom>
+          <a:noFill/>
+        </p:spPr>
+        <p:txBody>
+          <a:bodyPr wrap="square" lIns="0" tIns="0" rIns="0" bIns="0" anchor="ctr"/>
+          <a:lstStyle/>
+          <a:p>
+            <a:pPr marL="0" indent="0" algn="ctr">
+              <a:buNone/>
+            </a:pPr>
+            <a:r>
+              <a:rPr lang="en-US" sz="2200" b="1">
+                <a:solidFill>
+                  <a:srgbClr val="1976D2"/>
+                </a:solidFill>
+                <a:latin typeface="Calibri"/>
+                <a:ea typeface="Calibri"/>
+                <a:cs typeface="Calibri"/>
+              </a:rPr>
+              <a:t>Bukti 7 | Repo materi di GitHub</a:t>
+            </a:r>
+            <a:endParaRPr sz="2200"/>
+          </a:p>
+        </p:txBody>
+      </p:sp>
+      <p:sp>
+        <p:nvSpPr>
+          <p:cNvPr id="9" name="Text 5">
+            <a:extLst>
+              <a:ext uri="{FF2B5EF4-FFF2-40B4-BE49-F238E27FC236}">
+                <a16:creationId xmlns:a16="http://schemas.microsoft.com/office/drawing/2014/main" id="{E9D83C3F-92FF-40F8-8BF2-3617BA4D6782}"/>
+              </a:ext>
+            </a:extLst>
+          </p:cNvPr>
+          <p:cNvSpPr>
+            <a:spLocks noGrp="1"/>
+          </p:cNvSpPr>
+          <p:nvPr/>
+        </p:nvSpPr>
+        <p:spPr>
+          <a:xfrm>
+            <a:off x="457200" y="960120"/>
+            <a:ext cx="11247120" cy="320040"/>
+          </a:xfrm>
+          <a:prstGeom prst="rect">
+            <a:avLst/>
+          </a:prstGeom>
+          <a:noFill/>
+        </p:spPr>
+        <p:txBody>
+          <a:bodyPr wrap="square" lIns="0" tIns="0" rIns="0" bIns="0" anchor="ctr"/>
+          <a:lstStyle/>
+          <a:p>
+            <a:pPr marL="0" indent="0" algn="ctr">
+              <a:buNone/>
+            </a:pPr>
+            <a:r>
+              <a:rPr lang="en-US" sz="1200" i="1">
+                <a:solidFill>
+                  <a:srgbClr val="64748B"/>
+                </a:solidFill>
+                <a:latin typeface="Calibri"/>
+                <a:ea typeface="Calibri"/>
+                <a:cs typeface="Calibri"/>
+              </a:rPr>
+              <a:t>Source, modul PDF, slide, dan screenshot tersedia pada branch main</a:t>
+            </a:r>
+            <a:endParaRPr sz="1200"/>
+          </a:p>
+        </p:txBody>
+      </p:sp>
+      <p:sp>
+        <p:nvSpPr>
+          <p:cNvPr id="10" name="Shape 6">
+            <a:extLst>
+              <a:ext uri="{FF2B5EF4-FFF2-40B4-BE49-F238E27FC236}">
+                <a16:creationId xmlns:a16="http://schemas.microsoft.com/office/drawing/2014/main" id="{39AD2CC0-61EE-42D9-84B2-3CF9D3891AA5}"/>
+              </a:ext>
+            </a:extLst>
+          </p:cNvPr>
+          <p:cNvSpPr>
+            <a:spLocks noGrp="1"/>
+          </p:cNvSpPr>
+          <p:nvPr/>
+        </p:nvSpPr>
+        <p:spPr>
+          <a:xfrm>
+            <a:off x="457200" y="1417320"/>
+            <a:ext cx="5577840" cy="4754880"/>
+          </a:xfrm>
+          <a:prstGeom prst="rect">
+            <a:avLst/>
+          </a:prstGeom>
+          <a:solidFill>
+            <a:srgbClr val="F8FAFC"/>
+          </a:solidFill>
+          <a:ln w="12700">
+            <a:solidFill>
+              <a:srgbClr val="E2E8F0"/>
+            </a:solidFill>
+            <a:prstDash val="solid"/>
+          </a:ln>
+        </p:spPr>
+        <p:txBody>
+          <a:bodyPr/>
+          <a:p/>
+        </p:txBody>
+      </p:sp>
+      <p:sp>
+        <p:nvSpPr>
+          <p:cNvPr id="11" name="Text 7">
+            <a:extLst>
+              <a:ext uri="{FF2B5EF4-FFF2-40B4-BE49-F238E27FC236}">
+                <a16:creationId xmlns:a16="http://schemas.microsoft.com/office/drawing/2014/main" id="{1DEACE7B-1739-4C81-BED9-41CCEFF632A7}"/>
+              </a:ext>
+            </a:extLst>
+          </p:cNvPr>
+          <p:cNvSpPr>
+            <a:spLocks noGrp="1"/>
+          </p:cNvSpPr>
+          <p:nvPr/>
+        </p:nvSpPr>
+        <p:spPr>
+          <a:xfrm>
+            <a:off x="685800" y="1600200"/>
+            <a:ext cx="5120640" cy="822960"/>
+          </a:xfrm>
+          <a:prstGeom prst="rect">
+            <a:avLst/>
+          </a:prstGeom>
+          <a:noFill/>
+        </p:spPr>
+        <p:txBody>
+          <a:bodyPr wrap="square" lIns="0" tIns="0" rIns="0" bIns="0" anchor="ctr"/>
+          <a:lstStyle/>
+          <a:p>
+            <a:pPr marL="0" indent="0">
+              <a:buNone/>
+            </a:pPr>
+            <a:r>
+              <a:rPr lang="en-US" sz="1100" b="1" spc="300">
+                <a:solidFill>
+                  <a:srgbClr val="F37021"/>
+                </a:solidFill>
+                <a:latin typeface="Calibri"/>
+                <a:ea typeface="Calibri"/>
+                <a:cs typeface="Calibri"/>
+              </a:rPr>
+              <a:t>PERINTAH, FUNGSI, DAN HASIL</a:t>
+            </a:r>
+            <a:endParaRPr sz="1100"/>
+          </a:p>
+        </p:txBody>
+      </p:sp>
+      <p:pic>
+        <p:nvPicPr>
+          <p:cNvPr id="50" name="Image 2"/>
+          <p:cNvPicPr>
+            <a:picLocks noChangeAspect="1"/>
+          </p:cNvPicPr>
+          <p:nvPr/>
+        </p:nvPicPr>
+        <p:blipFill>
+          <a:blip r:embed="rId8"/>
+          <a:stretch>
+            <a:fillRect/>
+          </a:stretch>
+        </p:blipFill>
+        <p:spPr>
+          <a:xfrm>
+            <a:off x="777240" y="2697480"/>
+            <a:ext cx="292608" cy="292608"/>
+          </a:xfrm>
+          <a:prstGeom prst="rect">
+            <a:avLst/>
+          </a:prstGeom>
+        </p:spPr>
+      </p:pic>
+      <p:sp>
+        <p:nvSpPr>
+          <p:cNvPr id="13" name="Text 8">
+            <a:extLst>
+              <a:ext uri="{FF2B5EF4-FFF2-40B4-BE49-F238E27FC236}">
+                <a16:creationId xmlns:a16="http://schemas.microsoft.com/office/drawing/2014/main" id="{B993A3C2-6EAF-49D8-8850-74D4957F6B0D}"/>
+              </a:ext>
+            </a:extLst>
+          </p:cNvPr>
+          <p:cNvSpPr>
+            <a:spLocks noGrp="1"/>
+          </p:cNvSpPr>
+          <p:nvPr/>
+        </p:nvSpPr>
+        <p:spPr>
+          <a:xfrm>
+            <a:off x="1207008" y="2606040"/>
+            <a:ext cx="4709160" cy="457200"/>
+          </a:xfrm>
+          <a:prstGeom prst="rect">
+            <a:avLst/>
+          </a:prstGeom>
+          <a:noFill/>
+        </p:spPr>
+        <p:txBody>
+          <a:bodyPr wrap="square" lIns="0" tIns="0" rIns="0" bIns="0" anchor="ctr"/>
+          <a:lstStyle/>
+          <a:p>
+            <a:pPr marL="0" indent="0">
+              <a:buNone/>
+            </a:pPr>
+            <a:r>
+              <a:rPr lang="nl-NL" sz="1400">
+                <a:solidFill>
+                  <a:srgbClr val="312124"/>
+                </a:solidFill>
+                <a:latin typeface="Aptos" panose="020B0004020202020204" pitchFamily="34" charset="0"/>
+                <a:ea typeface="Calibri"/>
+                <a:cs typeface="Calibri"/>
+              </a:rPr>
+              <a:t>git status --short memeriksa perubahan.</a:t>
+            </a:r>
+            <a:endParaRPr sz="1400">
+              <a:solidFill>
+                <a:srgbClr val="312124"/>
+              </a:solidFill>
+              <a:latin typeface="Aptos" panose="020B0004020202020204" pitchFamily="34" charset="0"/>
+            </a:endParaRPr>
+          </a:p>
+        </p:txBody>
+      </p:sp>
+      <p:pic>
+        <p:nvPicPr>
+          <p:cNvPr id="52" name="Image 3"/>
+          <p:cNvPicPr>
+            <a:picLocks noChangeAspect="1"/>
+          </p:cNvPicPr>
+          <p:nvPr/>
+        </p:nvPicPr>
+        <p:blipFill>
+          <a:blip r:embed="rId6"/>
+          <a:stretch>
+            <a:fillRect/>
+          </a:stretch>
+        </p:blipFill>
+        <p:spPr>
+          <a:xfrm>
+            <a:off x="777240" y="3200400"/>
+            <a:ext cx="292608" cy="292608"/>
+          </a:xfrm>
+          <a:prstGeom prst="rect">
+            <a:avLst/>
+          </a:prstGeom>
+        </p:spPr>
+      </p:pic>
+      <p:sp>
+        <p:nvSpPr>
+          <p:cNvPr id="15" name="Text 9">
+            <a:extLst>
+              <a:ext uri="{FF2B5EF4-FFF2-40B4-BE49-F238E27FC236}">
+                <a16:creationId xmlns:a16="http://schemas.microsoft.com/office/drawing/2014/main" id="{9F558DEE-51B4-41EE-AF8A-83EE748013D9}"/>
+              </a:ext>
+            </a:extLst>
+          </p:cNvPr>
+          <p:cNvSpPr>
+            <a:spLocks noGrp="1"/>
+          </p:cNvSpPr>
+          <p:nvPr/>
+        </p:nvSpPr>
+        <p:spPr>
+          <a:xfrm>
+            <a:off x="1207008" y="3108960"/>
+            <a:ext cx="4709160" cy="457200"/>
+          </a:xfrm>
+          <a:prstGeom prst="rect">
+            <a:avLst/>
+          </a:prstGeom>
+          <a:noFill/>
+        </p:spPr>
+        <p:txBody>
+          <a:bodyPr wrap="square" lIns="0" tIns="0" rIns="0" bIns="0" anchor="ctr"/>
+          <a:lstStyle/>
+          <a:p>
+            <a:pPr marL="0" indent="0">
+              <a:buNone/>
+            </a:pPr>
+            <a:r>
+              <a:rPr lang="en-US" sz="1400">
+                <a:solidFill>
+                  <a:srgbClr val="312124"/>
+                </a:solidFill>
+                <a:latin typeface="Aptos" panose="020B0004020202020204" pitchFamily="34" charset="0"/>
+                <a:ea typeface="Calibri"/>
+                <a:cs typeface="Calibri"/>
+              </a:rPr>
+              <a:t>git add . menyiapkan berkas laporan.</a:t>
+            </a:r>
+            <a:endParaRPr sz="1400">
+              <a:solidFill>
+                <a:srgbClr val="312124"/>
+              </a:solidFill>
+              <a:latin typeface="Aptos" panose="020B0004020202020204" pitchFamily="34" charset="0"/>
+            </a:endParaRPr>
+          </a:p>
+        </p:txBody>
+      </p:sp>
+      <p:pic>
+        <p:nvPicPr>
+          <p:cNvPr id="54" name="Image 4"/>
+          <p:cNvPicPr>
+            <a:picLocks noChangeAspect="1"/>
+          </p:cNvPicPr>
+          <p:nvPr/>
+        </p:nvPicPr>
+        <p:blipFill>
+          <a:blip r:embed="rId4"/>
+          <a:stretch>
+            <a:fillRect/>
+          </a:stretch>
+        </p:blipFill>
+        <p:spPr>
+          <a:xfrm>
+            <a:off x="777240" y="3703320"/>
+            <a:ext cx="292608" cy="292608"/>
+          </a:xfrm>
+          <a:prstGeom prst="rect">
+            <a:avLst/>
+          </a:prstGeom>
+        </p:spPr>
+      </p:pic>
+      <p:sp>
+        <p:nvSpPr>
+          <p:cNvPr id="17" name="Text 10">
+            <a:extLst>
+              <a:ext uri="{FF2B5EF4-FFF2-40B4-BE49-F238E27FC236}">
+                <a16:creationId xmlns:a16="http://schemas.microsoft.com/office/drawing/2014/main" id="{CCBD09FF-8377-4C55-913D-4518EEC3F039}"/>
+              </a:ext>
+            </a:extLst>
+          </p:cNvPr>
+          <p:cNvSpPr>
+            <a:spLocks noGrp="1"/>
+          </p:cNvSpPr>
+          <p:nvPr/>
+        </p:nvSpPr>
+        <p:spPr>
+          <a:xfrm>
+            <a:off x="1207008" y="3611880"/>
+            <a:ext cx="4709160" cy="457200"/>
+          </a:xfrm>
+          <a:prstGeom prst="rect">
+            <a:avLst/>
+          </a:prstGeom>
+          <a:noFill/>
+        </p:spPr>
+        <p:txBody>
+          <a:bodyPr wrap="square" lIns="0" tIns="0" rIns="0" bIns="0" anchor="ctr"/>
+          <a:lstStyle/>
+          <a:p>
+            <a:pPr marL="0" indent="0">
+              <a:buNone/>
+            </a:pPr>
+            <a:r>
+              <a:rPr lang="en-US" sz="1400">
+                <a:solidFill>
+                  <a:srgbClr val="312124"/>
+                </a:solidFill>
+                <a:latin typeface="Aptos" panose="020B0004020202020204" pitchFamily="34" charset="0"/>
+                <a:ea typeface="Calibri"/>
+                <a:cs typeface="Calibri"/>
+              </a:rPr>
+              <a:t>git diff --cached --check mengecek diff.</a:t>
+            </a:r>
+            <a:endParaRPr sz="1400">
+              <a:solidFill>
+                <a:srgbClr val="312124"/>
+              </a:solidFill>
+              <a:latin typeface="Aptos" panose="020B0004020202020204" pitchFamily="34" charset="0"/>
+            </a:endParaRPr>
+          </a:p>
+        </p:txBody>
+      </p:sp>
+      <p:pic>
+        <p:nvPicPr>
+          <p:cNvPr id="56" name="Image 5"/>
+          <p:cNvPicPr>
+            <a:picLocks noChangeAspect="1"/>
+          </p:cNvPicPr>
+          <p:nvPr/>
+        </p:nvPicPr>
+        <p:blipFill>
+          <a:blip r:embed="rId2"/>
+          <a:stretch>
+            <a:fillRect/>
+          </a:stretch>
+        </p:blipFill>
+        <p:spPr>
+          <a:xfrm>
+            <a:off x="777240" y="4206240"/>
+            <a:ext cx="292608" cy="292608"/>
+          </a:xfrm>
+          <a:prstGeom prst="rect">
+            <a:avLst/>
+          </a:prstGeom>
+        </p:spPr>
+      </p:pic>
+      <p:sp>
+        <p:nvSpPr>
+          <p:cNvPr id="19" name="Text 11">
+            <a:extLst>
+              <a:ext uri="{FF2B5EF4-FFF2-40B4-BE49-F238E27FC236}">
+                <a16:creationId xmlns:a16="http://schemas.microsoft.com/office/drawing/2014/main" id="{4197262A-344D-4D9E-8886-0F68EE0A9D3D}"/>
+              </a:ext>
+            </a:extLst>
+          </p:cNvPr>
+          <p:cNvSpPr>
+            <a:spLocks noGrp="1"/>
+          </p:cNvSpPr>
+          <p:nvPr/>
+        </p:nvSpPr>
+        <p:spPr>
+          <a:xfrm>
+            <a:off x="1207008" y="4114800"/>
+            <a:ext cx="4709160" cy="457200"/>
+          </a:xfrm>
+          <a:prstGeom prst="rect">
+            <a:avLst/>
+          </a:prstGeom>
+          <a:noFill/>
+        </p:spPr>
+        <p:txBody>
+          <a:bodyPr wrap="square" lIns="0" tIns="0" rIns="0" bIns="0" anchor="ctr"/>
+          <a:lstStyle/>
+          <a:p>
+            <a:pPr marL="0" indent="0">
+              <a:buNone/>
+            </a:pPr>
+            <a:r>
+              <a:rPr lang="nl-NL" sz="1400">
+                <a:solidFill>
+                  <a:srgbClr val="312124"/>
+                </a:solidFill>
+                <a:latin typeface="Aptos" panose="020B0004020202020204" pitchFamily="34" charset="0"/>
+                <a:ea typeface="Calibri"/>
+                <a:cs typeface="Calibri"/>
+              </a:rPr>
+              <a:t>git commit mencatat versi pekerjaan.</a:t>
+            </a:r>
+            <a:endParaRPr sz="1400">
+              <a:solidFill>
+                <a:srgbClr val="312124"/>
+              </a:solidFill>
+              <a:latin typeface="Aptos" panose="020B0004020202020204" pitchFamily="34" charset="0"/>
+            </a:endParaRPr>
+          </a:p>
+        </p:txBody>
+      </p:sp>
+      <p:pic>
+        <p:nvPicPr>
+          <p:cNvPr id="58" name="Image 6"/>
+          <p:cNvPicPr>
+            <a:picLocks noChangeAspect="1"/>
+          </p:cNvPicPr>
+          <p:nvPr/>
+        </p:nvPicPr>
+        <p:blipFill>
+          <a:blip r:embed="rId11"/>
+          <a:stretch>
+            <a:fillRect/>
+          </a:stretch>
+        </p:blipFill>
+        <p:spPr>
+          <a:xfrm>
+            <a:off x="777240" y="4709160"/>
+            <a:ext cx="292608" cy="292608"/>
+          </a:xfrm>
+          <a:prstGeom prst="rect">
+            <a:avLst/>
+          </a:prstGeom>
+        </p:spPr>
+      </p:pic>
+      <p:sp>
+        <p:nvSpPr>
+          <p:cNvPr id="21" name="Text 12">
+            <a:extLst>
+              <a:ext uri="{FF2B5EF4-FFF2-40B4-BE49-F238E27FC236}">
+                <a16:creationId xmlns:a16="http://schemas.microsoft.com/office/drawing/2014/main" id="{4BCCC600-E174-44E9-BA7E-E3D863EF3980}"/>
+              </a:ext>
+            </a:extLst>
+          </p:cNvPr>
+          <p:cNvSpPr>
+            <a:spLocks noGrp="1"/>
+          </p:cNvSpPr>
+          <p:nvPr/>
+        </p:nvSpPr>
+        <p:spPr>
+          <a:xfrm>
+            <a:off x="1207008" y="4617720"/>
+            <a:ext cx="4709160" cy="457200"/>
+          </a:xfrm>
+          <a:prstGeom prst="rect">
+            <a:avLst/>
+          </a:prstGeom>
+          <a:noFill/>
+        </p:spPr>
+        <p:txBody>
+          <a:bodyPr wrap="square" lIns="0" tIns="0" rIns="0" bIns="0" anchor="ctr"/>
+          <a:lstStyle/>
+          <a:p>
+            <a:pPr marL="0" indent="0">
+              <a:buNone/>
+            </a:pPr>
+            <a:r>
+              <a:rPr lang="en-US" sz="1400">
+                <a:solidFill>
+                  <a:srgbClr val="312124"/>
+                </a:solidFill>
+                <a:latin typeface="Aptos" panose="020B0004020202020204" pitchFamily="34" charset="0"/>
+                <a:ea typeface="Calibri"/>
+                <a:cs typeface="Calibri"/>
+              </a:rPr>
+              <a:t>git push mengirim commit ke GitHub.</a:t>
+            </a:r>
+            <a:endParaRPr sz="1400">
+              <a:solidFill>
+                <a:srgbClr val="312124"/>
+              </a:solidFill>
+              <a:latin typeface="Aptos" panose="020B0004020202020204" pitchFamily="34" charset="0"/>
+            </a:endParaRPr>
+          </a:p>
+        </p:txBody>
+      </p:sp>
+      <p:pic>
+        <p:nvPicPr>
+          <p:cNvPr id="60" name="Image 7"/>
+          <p:cNvPicPr>
+            <a:picLocks noChangeAspect="1"/>
+          </p:cNvPicPr>
+          <p:nvPr/>
+        </p:nvPicPr>
+        <p:blipFill>
+          <a:blip r:embed="rId9"/>
+          <a:stretch>
+            <a:fillRect/>
+          </a:stretch>
+        </p:blipFill>
+        <p:spPr>
+          <a:xfrm>
+            <a:off x="777240" y="5212080"/>
+            <a:ext cx="292608" cy="292608"/>
+          </a:xfrm>
+          <a:prstGeom prst="rect">
+            <a:avLst/>
+          </a:prstGeom>
+        </p:spPr>
+      </p:pic>
+      <p:sp>
+        <p:nvSpPr>
+          <p:cNvPr id="23" name="Text 13">
+            <a:extLst>
+              <a:ext uri="{FF2B5EF4-FFF2-40B4-BE49-F238E27FC236}">
+                <a16:creationId xmlns:a16="http://schemas.microsoft.com/office/drawing/2014/main" id="{51C282E5-98A2-492C-A0FB-858F4827F279}"/>
+              </a:ext>
+            </a:extLst>
+          </p:cNvPr>
+          <p:cNvSpPr>
+            <a:spLocks noGrp="1"/>
+          </p:cNvSpPr>
+          <p:nvPr/>
+        </p:nvSpPr>
+        <p:spPr>
+          <a:xfrm>
+            <a:off x="1207008" y="5120640"/>
+            <a:ext cx="4709160" cy="457200"/>
+          </a:xfrm>
+          <a:prstGeom prst="rect">
+            <a:avLst/>
+          </a:prstGeom>
+          <a:noFill/>
+        </p:spPr>
+        <p:txBody>
+          <a:bodyPr wrap="square" lIns="0" tIns="0" rIns="0" bIns="0" anchor="ctr"/>
+          <a:lstStyle/>
+          <a:p>
+            <a:pPr marL="0" indent="0">
+              <a:buNone/>
+            </a:pPr>
+            <a:r>
+              <a:rPr lang="en-US" sz="1400">
+                <a:solidFill>
+                  <a:srgbClr val="312124"/>
+                </a:solidFill>
+                <a:latin typeface="Aptos" panose="020B0004020202020204" pitchFamily="34" charset="0"/>
+                <a:ea typeface="Calibri"/>
+                <a:cs typeface="Calibri"/>
+              </a:rPr>
+              <a:t>Repo materi publik bertanda template.</a:t>
+            </a:r>
+            <a:endParaRPr sz="1400">
+              <a:solidFill>
+                <a:srgbClr val="312124"/>
+              </a:solidFill>
+              <a:latin typeface="Aptos" panose="020B0004020202020204" pitchFamily="34" charset="0"/>
+            </a:endParaRPr>
+          </a:p>
+        </p:txBody>
+      </p:sp>
+      <p:pic>
+        <p:nvPicPr>
+          <p:cNvPr id="62" name="Image 8"/>
+          <p:cNvPicPr>
+            <a:picLocks noChangeAspect="1"/>
+          </p:cNvPicPr>
+          <p:nvPr/>
+        </p:nvPicPr>
+        <p:blipFill>
+          <a:blip r:embed="rId7"/>
+          <a:stretch>
+            <a:fillRect/>
+          </a:stretch>
+        </p:blipFill>
+        <p:spPr>
+          <a:xfrm>
+            <a:off x="777240" y="5715000"/>
+            <a:ext cx="292608" cy="292608"/>
+          </a:xfrm>
+          <a:prstGeom prst="rect">
+            <a:avLst/>
+          </a:prstGeom>
+        </p:spPr>
+      </p:pic>
+      <p:sp>
+        <p:nvSpPr>
+          <p:cNvPr id="25" name="Text 14">
+            <a:extLst>
+              <a:ext uri="{FF2B5EF4-FFF2-40B4-BE49-F238E27FC236}">
+                <a16:creationId xmlns:a16="http://schemas.microsoft.com/office/drawing/2014/main" id="{B177279E-DD89-4D39-980E-854DCABC1443}"/>
+              </a:ext>
+            </a:extLst>
+          </p:cNvPr>
+          <p:cNvSpPr>
+            <a:spLocks noGrp="1"/>
+          </p:cNvSpPr>
+          <p:nvPr/>
+        </p:nvSpPr>
+        <p:spPr>
+          <a:xfrm>
+            <a:off x="1207008" y="5623560"/>
+            <a:ext cx="4709160" cy="457200"/>
+          </a:xfrm>
+          <a:prstGeom prst="rect">
+            <a:avLst/>
+          </a:prstGeom>
+          <a:noFill/>
+        </p:spPr>
+        <p:txBody>
+          <a:bodyPr wrap="square" lIns="0" tIns="0" rIns="0" bIns="0" anchor="ctr"/>
+          <a:lstStyle/>
+          <a:p>
+            <a:pPr marL="0" indent="0">
+              <a:buNone/>
+            </a:pPr>
+            <a:r>
+              <a:rPr lang="en-US" sz="1400">
+                <a:solidFill>
+                  <a:srgbClr val="312124"/>
+                </a:solidFill>
+                <a:latin typeface="Aptos" panose="020B0004020202020204" pitchFamily="34" charset="0"/>
+                <a:ea typeface="Calibri"/>
+                <a:cs typeface="Calibri"/>
+              </a:rPr>
+              <a:t>Mahasiswa tetap memakai repo miliknya.</a:t>
+            </a:r>
+            <a:endParaRPr sz="1400">
+              <a:solidFill>
+                <a:srgbClr val="312124"/>
+              </a:solidFill>
+              <a:latin typeface="Aptos" panose="020B0004020202020204" pitchFamily="34" charset="0"/>
+            </a:endParaRPr>
+          </a:p>
+        </p:txBody>
+      </p:sp>
+      <p:sp>
+        <p:nvSpPr>
+          <p:cNvPr id="26" name="Shape 15">
+            <a:extLst>
+              <a:ext uri="{FF2B5EF4-FFF2-40B4-BE49-F238E27FC236}">
+                <a16:creationId xmlns:a16="http://schemas.microsoft.com/office/drawing/2014/main" id="{C7B4490A-FFF5-41D3-9C52-A0C33420C96E}"/>
+              </a:ext>
+            </a:extLst>
+          </p:cNvPr>
+          <p:cNvSpPr>
+            <a:spLocks noGrp="1"/>
+          </p:cNvSpPr>
+          <p:nvPr/>
+        </p:nvSpPr>
+        <p:spPr>
+          <a:xfrm>
+            <a:off x="6217920" y="1417320"/>
+            <a:ext cx="5486400" cy="4754880"/>
+          </a:xfrm>
+          <a:prstGeom prst="rect">
+            <a:avLst/>
+          </a:prstGeom>
+          <a:solidFill>
+            <a:srgbClr val="002677"/>
+          </a:solidFill>
+          <a:ln w="12700">
+            <a:solidFill>
+              <a:srgbClr val="002677"/>
+            </a:solidFill>
+            <a:prstDash val="solid"/>
+          </a:ln>
+        </p:spPr>
+        <p:txBody>
+          <a:bodyPr/>
+          <a:p/>
+        </p:txBody>
+      </p:sp>
+      <p:sp>
+        <p:nvSpPr>
+          <p:cNvPr id="27" name="Text 16">
+            <a:extLst>
+              <a:ext uri="{FF2B5EF4-FFF2-40B4-BE49-F238E27FC236}">
+                <a16:creationId xmlns:a16="http://schemas.microsoft.com/office/drawing/2014/main" id="{20AA4EB3-BFF5-4F16-A7A7-B59505236308}"/>
+              </a:ext>
+            </a:extLst>
+          </p:cNvPr>
+          <p:cNvSpPr>
+            <a:spLocks noGrp="1"/>
+          </p:cNvSpPr>
+          <p:nvPr/>
+        </p:nvSpPr>
+        <p:spPr>
+          <a:xfrm>
+            <a:off x="6446520" y="1508760"/>
+            <a:ext cx="5120640" cy="457200"/>
+          </a:xfrm>
+          <a:prstGeom prst="rect">
+            <a:avLst/>
+          </a:prstGeom>
+          <a:noFill/>
+        </p:spPr>
+        <p:txBody>
+          <a:bodyPr wrap="square" lIns="0" tIns="0" rIns="0" bIns="0" anchor="ctr"/>
+          <a:lstStyle/>
+          <a:p>
+            <a:pPr marL="0" indent="0">
+              <a:buNone/>
+            </a:pPr>
+            <a:r>
+              <a:rPr lang="en-US" sz="1100" b="1" spc="300">
+                <a:solidFill>
+                  <a:srgbClr val="F37021"/>
+                </a:solidFill>
+                <a:latin typeface="Calibri"/>
+                <a:ea typeface="Calibri"/>
+                <a:cs typeface="Calibri"/>
+              </a:rPr>
+              <a:t>BUKTI PADA MESIN UJI</a:t>
+            </a:r>
+            <a:endParaRPr sz="1100"/>
+          </a:p>
+        </p:txBody>
+      </p:sp>
+      <p:sp>
+        <p:nvSpPr>
+          <p:cNvPr id="28" name="Text 17">
+            <a:extLst>
+              <a:ext uri="{FF2B5EF4-FFF2-40B4-BE49-F238E27FC236}">
+                <a16:creationId xmlns:a16="http://schemas.microsoft.com/office/drawing/2014/main" id="{A510FF9F-C5D6-4E2D-85B2-09BE823938C7}"/>
+              </a:ext>
+            </a:extLst>
+          </p:cNvPr>
+          <p:cNvSpPr>
+            <a:spLocks noGrp="1"/>
+          </p:cNvSpPr>
+          <p:nvPr/>
+        </p:nvSpPr>
+        <p:spPr>
+          <a:xfrm>
+            <a:off x="6446520" y="2606040"/>
+            <a:ext cx="5029200" cy="2743200"/>
+          </a:xfrm>
+          <a:prstGeom prst="rect">
+            <a:avLst/>
+          </a:prstGeom>
+          <a:noFill/>
+        </p:spPr>
+        <p:txBody>
+          <a:bodyPr wrap="square" anchor="ctr"/>
+          <a:lstStyle/>
+          <a:p>
+            <a:pPr marL="0" indent="0">
+              <a:spcAft>
+                <a:spcPts val="600"/>
+              </a:spcAft>
+              <a:buNone/>
+            </a:pPr>
+            <a:endParaRPr sz="1200"/>
+          </a:p>
+        </p:txBody>
+      </p:sp>
+      <p:sp>
+        <p:nvSpPr>
+          <p:cNvPr id="29" name="Shape 18">
+            <a:extLst>
+              <a:ext uri="{FF2B5EF4-FFF2-40B4-BE49-F238E27FC236}">
+                <a16:creationId xmlns:a16="http://schemas.microsoft.com/office/drawing/2014/main" id="{AC58595B-EA01-4E90-92F0-726DDB18DDF6}"/>
+              </a:ext>
+            </a:extLst>
+          </p:cNvPr>
+          <p:cNvSpPr>
+            <a:spLocks noGrp="1"/>
+          </p:cNvSpPr>
+          <p:nvPr/>
+        </p:nvSpPr>
+        <p:spPr>
+          <a:xfrm>
+            <a:off x="6446520" y="5349240"/>
+            <a:ext cx="5029200" cy="731520"/>
+          </a:xfrm>
+          <a:prstGeom prst="rect">
+            <a:avLst/>
+          </a:prstGeom>
+          <a:solidFill>
+            <a:srgbClr val="F37021"/>
+          </a:solidFill>
+          <a:ln w="12700">
+            <a:solidFill>
+              <a:srgbClr val="F37021"/>
+            </a:solidFill>
+            <a:prstDash val="solid"/>
+          </a:ln>
+        </p:spPr>
+        <p:txBody>
+          <a:bodyPr/>
+          <a:p/>
+        </p:txBody>
+      </p:sp>
+      <p:sp>
+        <p:nvSpPr>
+          <p:cNvPr id="30" name="Text 19">
+            <a:extLst>
+              <a:ext uri="{FF2B5EF4-FFF2-40B4-BE49-F238E27FC236}">
+                <a16:creationId xmlns:a16="http://schemas.microsoft.com/office/drawing/2014/main" id="{1DD7F142-14F2-4CB5-A97B-19F12807B76A}"/>
+              </a:ext>
+            </a:extLst>
+          </p:cNvPr>
+          <p:cNvSpPr>
+            <a:spLocks noGrp="1"/>
+          </p:cNvSpPr>
+          <p:nvPr/>
+        </p:nvSpPr>
+        <p:spPr>
+          <a:xfrm>
+            <a:off x="6446520" y="5349240"/>
+            <a:ext cx="5029200" cy="731520"/>
+          </a:xfrm>
+          <a:prstGeom prst="rect">
+            <a:avLst/>
+          </a:prstGeom>
+          <a:noFill/>
+        </p:spPr>
+        <p:txBody>
+          <a:bodyPr wrap="square" lIns="0" tIns="0" rIns="0" bIns="0" anchor="ctr"/>
+          <a:lstStyle/>
+          <a:p>
+            <a:pPr marL="0" indent="0" algn="ctr">
+              <a:buNone/>
+            </a:pPr>
+            <a:r>
+              <a:rPr lang="fi-FI" sz="1500" i="1">
+                <a:solidFill>
+                  <a:srgbClr val="FFFFFF"/>
+                </a:solidFill>
+                <a:latin typeface="Aptos" panose="020B0004020202020204" pitchFamily="34" charset="0"/>
+                <a:ea typeface="Calibri"/>
+                <a:cs typeface="Calibri"/>
+              </a:rPr>
+              <a:t>Halaman ini bukti repo materi; bukan push mahasiswa.</a:t>
+            </a:r>
+            <a:endParaRPr sz="1500">
+              <a:solidFill>
+                <a:srgbClr val="FFFFFF"/>
+              </a:solidFill>
+              <a:latin typeface="Aptos" panose="020B0004020202020204" pitchFamily="34" charset="0"/>
+            </a:endParaRPr>
+          </a:p>
+        </p:txBody>
+      </p:sp>
+      <p:pic>
+        <p:nvPicPr>
+          <p:cNvPr id="63" name="Picture 62" descr="09_github_repo_aktual.png"/>
+          <p:cNvPicPr>
+            <a:picLocks noChangeAspect="1"/>
+          </p:cNvPicPr>
+          <p:nvPr/>
+        </p:nvPicPr>
+        <p:blipFill>
+          <a:blip r:embed="rId12"/>
+          <a:stretch>
+            <a:fillRect/>
+          </a:stretch>
+        </p:blipFill>
+        <p:spPr>
+          <a:xfrm>
+            <a:off x="6654680" y="2057400"/>
+            <a:ext cx="4612879" cy="3063240"/>
+          </a:xfrm>
+          <a:prstGeom prst="rect">
+            <a:avLst/>
+          </a:prstGeom>
+        </p:spPr>
+      </p:pic>
+    </p:spTree>
   </p:cSld>
   <p:clrMapOvr>
     <a:masterClrMapping/>
@@ -6372,6 +7676,10 @@
             <a:prstDash val="solid"/>
           </a:ln>
         </p:spPr>
+        <p:txBody>
+          <a:bodyPr/>
+          <a:p/>
+        </p:txBody>
       </p:sp>
       <p:pic>
         <p:nvPicPr>
@@ -6451,6 +7759,10 @@
             <a:prstDash val="solid"/>
           </a:ln>
         </p:spPr>
+        <p:txBody>
+          <a:bodyPr/>
+          <a:p/>
+        </p:txBody>
       </p:sp>
       <p:sp>
         <p:nvSpPr>
@@ -6576,6 +7888,10 @@
             <a:prstDash val="solid"/>
           </a:ln>
         </p:spPr>
+        <p:txBody>
+          <a:bodyPr/>
+          <a:p/>
+        </p:txBody>
       </p:sp>
       <p:sp>
         <p:nvSpPr>
@@ -7174,6 +8490,10 @@
             <a:prstDash val="solid"/>
           </a:ln>
         </p:spPr>
+        <p:txBody>
+          <a:bodyPr/>
+          <a:p/>
+        </p:txBody>
       </p:sp>
       <p:sp>
         <p:nvSpPr>
@@ -7388,6 +8708,10 @@
             <a:prstDash val="solid"/>
           </a:ln>
         </p:spPr>
+        <p:txBody>
+          <a:bodyPr/>
+          <a:p/>
+        </p:txBody>
       </p:sp>
       <p:sp>
         <p:nvSpPr>
@@ -7597,6 +8921,10 @@
             <a:prstDash val="solid"/>
           </a:ln>
         </p:spPr>
+        <p:txBody>
+          <a:bodyPr/>
+          <a:p/>
+        </p:txBody>
       </p:sp>
       <p:pic>
         <p:nvPicPr>
@@ -7676,6 +9004,10 @@
             <a:prstDash val="solid"/>
           </a:ln>
         </p:spPr>
+        <p:txBody>
+          <a:bodyPr/>
+          <a:p/>
+        </p:txBody>
       </p:sp>
       <p:sp>
         <p:nvSpPr>
@@ -7801,6 +9133,10 @@
             <a:prstDash val="solid"/>
           </a:ln>
         </p:spPr>
+        <p:txBody>
+          <a:bodyPr/>
+          <a:p/>
+        </p:txBody>
       </p:sp>
       <p:sp>
         <p:nvSpPr>
@@ -7834,6 +9170,10 @@
             <a:prstDash val="solid"/>
           </a:ln>
         </p:spPr>
+        <p:txBody>
+          <a:bodyPr/>
+          <a:p/>
+        </p:txBody>
       </p:sp>
       <p:sp>
         <p:nvSpPr>
@@ -7867,6 +9207,10 @@
             <a:prstDash val="solid"/>
           </a:ln>
         </p:spPr>
+        <p:txBody>
+          <a:bodyPr/>
+          <a:p/>
+        </p:txBody>
       </p:sp>
       <p:sp>
         <p:nvSpPr>
@@ -7900,6 +9244,10 @@
             <a:prstDash val="solid"/>
           </a:ln>
         </p:spPr>
+        <p:txBody>
+          <a:bodyPr/>
+          <a:p/>
+        </p:txBody>
       </p:sp>
       <p:sp>
         <p:nvSpPr>
@@ -7933,6 +9281,10 @@
             <a:prstDash val="solid"/>
           </a:ln>
         </p:spPr>
+        <p:txBody>
+          <a:bodyPr/>
+          <a:p/>
+        </p:txBody>
       </p:sp>
       <p:sp>
         <p:nvSpPr>
@@ -8080,6 +9432,10 @@
             <a:prstDash val="solid"/>
           </a:ln>
         </p:spPr>
+        <p:txBody>
+          <a:bodyPr/>
+          <a:p/>
+        </p:txBody>
       </p:sp>
       <p:sp>
         <p:nvSpPr>
@@ -8113,6 +9469,10 @@
             <a:prstDash val="solid"/>
           </a:ln>
         </p:spPr>
+        <p:txBody>
+          <a:bodyPr/>
+          <a:p/>
+        </p:txBody>
       </p:sp>
       <p:sp>
         <p:nvSpPr>
@@ -8146,6 +9506,10 @@
             <a:prstDash val="solid"/>
           </a:ln>
         </p:spPr>
+        <p:txBody>
+          <a:bodyPr/>
+          <a:p/>
+        </p:txBody>
       </p:sp>
       <p:sp>
         <p:nvSpPr>
@@ -8179,6 +9543,10 @@
             <a:prstDash val="solid"/>
           </a:ln>
         </p:spPr>
+        <p:txBody>
+          <a:bodyPr/>
+          <a:p/>
+        </p:txBody>
       </p:sp>
       <p:sp>
         <p:nvSpPr>
@@ -8212,6 +9580,10 @@
             <a:prstDash val="solid"/>
           </a:ln>
         </p:spPr>
+        <p:txBody>
+          <a:bodyPr/>
+          <a:p/>
+        </p:txBody>
       </p:sp>
       <p:sp>
         <p:nvSpPr>
@@ -8490,6 +9862,10 @@
             <a:prstDash val="solid"/>
           </a:ln>
         </p:spPr>
+        <p:txBody>
+          <a:bodyPr/>
+          <a:p/>
+        </p:txBody>
       </p:sp>
       <p:pic>
         <p:nvPicPr>
@@ -8569,6 +9945,10 @@
             <a:prstDash val="solid"/>
           </a:ln>
         </p:spPr>
+        <p:txBody>
+          <a:bodyPr/>
+          <a:p/>
+        </p:txBody>
       </p:sp>
       <p:sp>
         <p:nvSpPr>
@@ -8694,6 +10074,10 @@
             <a:prstDash val="solid"/>
           </a:ln>
         </p:spPr>
+        <p:txBody>
+          <a:bodyPr/>
+          <a:p/>
+        </p:txBody>
       </p:sp>
       <p:sp>
         <p:nvSpPr>
@@ -9298,6 +10682,10 @@
             <a:prstDash val="solid"/>
           </a:ln>
         </p:spPr>
+        <p:txBody>
+          <a:bodyPr/>
+          <a:p/>
+        </p:txBody>
       </p:sp>
       <p:sp>
         <p:nvSpPr>
@@ -9415,6 +10803,10 @@
             <a:prstDash val="solid"/>
           </a:ln>
         </p:spPr>
+        <p:txBody>
+          <a:bodyPr/>
+          <a:p/>
+        </p:txBody>
       </p:sp>
       <p:sp>
         <p:nvSpPr>
@@ -9665,6 +11057,10 @@
             <a:prstDash val="solid"/>
           </a:ln>
         </p:spPr>
+        <p:txBody>
+          <a:bodyPr/>
+          <a:p/>
+        </p:txBody>
       </p:sp>
       <p:pic>
         <p:nvPicPr>
@@ -9744,6 +11140,10 @@
             <a:prstDash val="solid"/>
           </a:ln>
         </p:spPr>
+        <p:txBody>
+          <a:bodyPr/>
+          <a:p/>
+        </p:txBody>
       </p:sp>
       <p:sp>
         <p:nvSpPr>
@@ -9869,6 +11269,10 @@
             <a:prstDash val="solid"/>
           </a:ln>
         </p:spPr>
+        <p:txBody>
+          <a:bodyPr/>
+          <a:p/>
+        </p:txBody>
       </p:sp>
       <p:sp>
         <p:nvSpPr>
@@ -9902,6 +11306,10 @@
             <a:prstDash val="solid"/>
           </a:ln>
         </p:spPr>
+        <p:txBody>
+          <a:bodyPr/>
+          <a:p/>
+        </p:txBody>
       </p:sp>
       <p:sp>
         <p:nvSpPr>
@@ -9935,6 +11343,10 @@
             <a:prstDash val="solid"/>
           </a:ln>
         </p:spPr>
+        <p:txBody>
+          <a:bodyPr/>
+          <a:p/>
+        </p:txBody>
       </p:sp>
       <p:sp>
         <p:nvSpPr>
@@ -9968,6 +11380,10 @@
             <a:prstDash val="solid"/>
           </a:ln>
         </p:spPr>
+        <p:txBody>
+          <a:bodyPr/>
+          <a:p/>
+        </p:txBody>
       </p:sp>
       <p:sp>
         <p:nvSpPr>
@@ -10001,6 +11417,10 @@
             <a:prstDash val="solid"/>
           </a:ln>
         </p:spPr>
+        <p:txBody>
+          <a:bodyPr/>
+          <a:p/>
+        </p:txBody>
       </p:sp>
       <p:sp>
         <p:nvSpPr>
@@ -10146,6 +11566,10 @@
             <a:prstDash val="solid"/>
           </a:ln>
         </p:spPr>
+        <p:txBody>
+          <a:bodyPr/>
+          <a:p/>
+        </p:txBody>
       </p:sp>
       <p:sp>
         <p:nvSpPr>
@@ -10179,6 +11603,10 @@
             <a:prstDash val="solid"/>
           </a:ln>
         </p:spPr>
+        <p:txBody>
+          <a:bodyPr/>
+          <a:p/>
+        </p:txBody>
       </p:sp>
       <p:sp>
         <p:nvSpPr>
@@ -10212,6 +11640,10 @@
             <a:prstDash val="solid"/>
           </a:ln>
         </p:spPr>
+        <p:txBody>
+          <a:bodyPr/>
+          <a:p/>
+        </p:txBody>
       </p:sp>
       <p:sp>
         <p:nvSpPr>
@@ -10245,6 +11677,10 @@
             <a:prstDash val="solid"/>
           </a:ln>
         </p:spPr>
+        <p:txBody>
+          <a:bodyPr/>
+          <a:p/>
+        </p:txBody>
       </p:sp>
       <p:sp>
         <p:nvSpPr>
@@ -10278,6 +11714,10 @@
             <a:prstDash val="solid"/>
           </a:ln>
         </p:spPr>
+        <p:txBody>
+          <a:bodyPr/>
+          <a:p/>
+        </p:txBody>
       </p:sp>
       <p:sp>
         <p:nvSpPr>
@@ -10556,6 +11996,10 @@
             <a:prstDash val="solid"/>
           </a:ln>
         </p:spPr>
+        <p:txBody>
+          <a:bodyPr/>
+          <a:p/>
+        </p:txBody>
       </p:sp>
       <p:pic>
         <p:nvPicPr>
@@ -10635,6 +12079,10 @@
             <a:prstDash val="solid"/>
           </a:ln>
         </p:spPr>
+        <p:txBody>
+          <a:bodyPr/>
+          <a:p/>
+        </p:txBody>
       </p:sp>
       <p:sp>
         <p:nvSpPr>
@@ -10760,6 +12208,10 @@
             <a:prstDash val="solid"/>
           </a:ln>
         </p:spPr>
+        <p:txBody>
+          <a:bodyPr/>
+          <a:p/>
+        </p:txBody>
       </p:sp>
       <p:sp>
         <p:nvSpPr>
@@ -11364,6 +12816,10 @@
             <a:prstDash val="solid"/>
           </a:ln>
         </p:spPr>
+        <p:txBody>
+          <a:bodyPr/>
+          <a:p/>
+        </p:txBody>
       </p:sp>
       <p:sp>
         <p:nvSpPr>
@@ -11481,6 +12937,10 @@
             <a:prstDash val="solid"/>
           </a:ln>
         </p:spPr>
+        <p:txBody>
+          <a:bodyPr/>
+          <a:p/>
+        </p:txBody>
       </p:sp>
       <p:sp>
         <p:nvSpPr>
@@ -11731,6 +13191,10 @@
             <a:prstDash val="solid"/>
           </a:ln>
         </p:spPr>
+        <p:txBody>
+          <a:bodyPr/>
+          <a:p/>
+        </p:txBody>
       </p:sp>
       <p:pic>
         <p:nvPicPr>
@@ -11810,6 +13274,10 @@
             <a:prstDash val="solid"/>
           </a:ln>
         </p:spPr>
+        <p:txBody>
+          <a:bodyPr/>
+          <a:p/>
+        </p:txBody>
       </p:sp>
       <p:sp>
         <p:nvSpPr>
@@ -11935,6 +13403,10 @@
             <a:prstDash val="solid"/>
           </a:ln>
         </p:spPr>
+        <p:txBody>
+          <a:bodyPr/>
+          <a:p/>
+        </p:txBody>
       </p:sp>
       <p:sp>
         <p:nvSpPr>
@@ -11968,6 +13440,10 @@
             <a:prstDash val="solid"/>
           </a:ln>
         </p:spPr>
+        <p:txBody>
+          <a:bodyPr/>
+          <a:p/>
+        </p:txBody>
       </p:sp>
       <p:sp>
         <p:nvSpPr>
@@ -12001,6 +13477,10 @@
             <a:prstDash val="solid"/>
           </a:ln>
         </p:spPr>
+        <p:txBody>
+          <a:bodyPr/>
+          <a:p/>
+        </p:txBody>
       </p:sp>
       <p:sp>
         <p:nvSpPr>
@@ -12034,6 +13514,10 @@
             <a:prstDash val="solid"/>
           </a:ln>
         </p:spPr>
+        <p:txBody>
+          <a:bodyPr/>
+          <a:p/>
+        </p:txBody>
       </p:sp>
       <p:sp>
         <p:nvSpPr>
@@ -12067,6 +13551,10 @@
             <a:prstDash val="solid"/>
           </a:ln>
         </p:spPr>
+        <p:txBody>
+          <a:bodyPr/>
+          <a:p/>
+        </p:txBody>
       </p:sp>
       <p:sp>
         <p:nvSpPr>
@@ -12213,6 +13701,10 @@
             <a:prstDash val="solid"/>
           </a:ln>
         </p:spPr>
+        <p:txBody>
+          <a:bodyPr/>
+          <a:p/>
+        </p:txBody>
       </p:sp>
       <p:sp>
         <p:nvSpPr>
@@ -12246,6 +13738,10 @@
             <a:prstDash val="solid"/>
           </a:ln>
         </p:spPr>
+        <p:txBody>
+          <a:bodyPr/>
+          <a:p/>
+        </p:txBody>
       </p:sp>
       <p:sp>
         <p:nvSpPr>
@@ -12279,6 +13775,10 @@
             <a:prstDash val="solid"/>
           </a:ln>
         </p:spPr>
+        <p:txBody>
+          <a:bodyPr/>
+          <a:p/>
+        </p:txBody>
       </p:sp>
       <p:sp>
         <p:nvSpPr>
@@ -12312,6 +13812,10 @@
             <a:prstDash val="solid"/>
           </a:ln>
         </p:spPr>
+        <p:txBody>
+          <a:bodyPr/>
+          <a:p/>
+        </p:txBody>
       </p:sp>
       <p:sp>
         <p:nvSpPr>
@@ -12345,6 +13849,10 @@
             <a:prstDash val="solid"/>
           </a:ln>
         </p:spPr>
+        <p:txBody>
+          <a:bodyPr/>
+          <a:p/>
+        </p:txBody>
       </p:sp>
       <p:sp>
         <p:nvSpPr>
@@ -12623,6 +14131,10 @@
             <a:prstDash val="solid"/>
           </a:ln>
         </p:spPr>
+        <p:txBody>
+          <a:bodyPr/>
+          <a:p/>
+        </p:txBody>
       </p:sp>
       <p:pic>
         <p:nvPicPr>
@@ -12702,6 +14214,10 @@
             <a:prstDash val="solid"/>
           </a:ln>
         </p:spPr>
+        <p:txBody>
+          <a:bodyPr/>
+          <a:p/>
+        </p:txBody>
       </p:sp>
       <p:sp>
         <p:nvSpPr>
@@ -12827,6 +14343,10 @@
             <a:prstDash val="solid"/>
           </a:ln>
         </p:spPr>
+        <p:txBody>
+          <a:bodyPr/>
+          <a:p/>
+        </p:txBody>
       </p:sp>
       <p:sp>
         <p:nvSpPr>
@@ -13431,6 +14951,10 @@
             <a:prstDash val="solid"/>
           </a:ln>
         </p:spPr>
+        <p:txBody>
+          <a:bodyPr/>
+          <a:p/>
+        </p:txBody>
       </p:sp>
       <p:sp>
         <p:nvSpPr>
@@ -13548,6 +15072,10 @@
             <a:prstDash val="solid"/>
           </a:ln>
         </p:spPr>
+        <p:txBody>
+          <a:bodyPr/>
+          <a:p/>
+        </p:txBody>
       </p:sp>
       <p:sp>
         <p:nvSpPr>
@@ -13798,6 +15326,10 @@
             <a:prstDash val="solid"/>
           </a:ln>
         </p:spPr>
+        <p:txBody>
+          <a:bodyPr/>
+          <a:p/>
+        </p:txBody>
       </p:sp>
       <p:pic>
         <p:nvPicPr>
@@ -13877,6 +15409,10 @@
             <a:prstDash val="solid"/>
           </a:ln>
         </p:spPr>
+        <p:txBody>
+          <a:bodyPr/>
+          <a:p/>
+        </p:txBody>
       </p:sp>
       <p:sp>
         <p:nvSpPr>
@@ -14002,6 +15538,10 @@
             <a:prstDash val="solid"/>
           </a:ln>
         </p:spPr>
+        <p:txBody>
+          <a:bodyPr/>
+          <a:p/>
+        </p:txBody>
       </p:sp>
       <p:sp>
         <p:nvSpPr>
@@ -14606,6 +16146,10 @@
             <a:prstDash val="solid"/>
           </a:ln>
         </p:spPr>
+        <p:txBody>
+          <a:bodyPr/>
+          <a:p/>
+        </p:txBody>
       </p:sp>
       <p:sp>
         <p:nvSpPr>
@@ -14723,6 +16267,10 @@
             <a:prstDash val="solid"/>
           </a:ln>
         </p:spPr>
+        <p:txBody>
+          <a:bodyPr/>
+          <a:p/>
+        </p:txBody>
       </p:sp>
       <p:sp>
         <p:nvSpPr>

</xml_diff>

<commit_message>
Align Lab 09 with group project and publish revised theory/practical slides
</commit_message>
<xml_diff>
--- a/slides/LAB09_Gradio_Sentiment_Bukti_Live.pptx
+++ b/slides/LAB09_Gradio_Sentiment_Bukti_Live.pptx
@@ -2,26 +2,26 @@
 <file path=ppt/presentation.xml><?xml version="1.0" encoding="utf-8"?>
 <p:presentation xmlns:p="http://schemas.openxmlformats.org/presentationml/2006/main">
   <p:sldMasterIdLst>
-    <p:sldMasterId xmlns:r="http://schemas.openxmlformats.org/officeDocument/2006/relationships" id="2147483648" r:id="Rb5f7381bd90a4aeb"/>
+    <p:sldMasterId xmlns:r="http://schemas.openxmlformats.org/officeDocument/2006/relationships" id="2147483648" r:id="R6289cb78ff3e48b7"/>
   </p:sldMasterIdLst>
   <p:notesMasterIdLst>
-    <p:notesMasterId xmlns:r="http://schemas.openxmlformats.org/officeDocument/2006/relationships" r:id="Rf48501f8d35b41b3"/>
+    <p:notesMasterId xmlns:r="http://schemas.openxmlformats.org/officeDocument/2006/relationships" r:id="Rd78d53735d394a76"/>
   </p:notesMasterIdLst>
   <p:sldIdLst>
-    <p:sldId xmlns:r="http://schemas.openxmlformats.org/officeDocument/2006/relationships" id="256" r:id="R5791f0f2f82d4a11"/>
-    <p:sldId xmlns:r="http://schemas.openxmlformats.org/officeDocument/2006/relationships" id="257" r:id="Rd4bd4994e21440ae"/>
-    <p:sldId xmlns:r="http://schemas.openxmlformats.org/officeDocument/2006/relationships" id="258" r:id="Rd56c65d149a94e4d"/>
-    <p:sldId xmlns:r="http://schemas.openxmlformats.org/officeDocument/2006/relationships" id="259" r:id="R367e4a2e17ca46ed"/>
-    <p:sldId xmlns:r="http://schemas.openxmlformats.org/officeDocument/2006/relationships" id="260" r:id="R7675862e96154ffa"/>
-    <p:sldId xmlns:r="http://schemas.openxmlformats.org/officeDocument/2006/relationships" id="261" r:id="R72a9ad5c418a4121"/>
-    <p:sldId xmlns:r="http://schemas.openxmlformats.org/officeDocument/2006/relationships" id="262" r:id="Re506260acb4b4f07"/>
-    <p:sldId xmlns:r="http://schemas.openxmlformats.org/officeDocument/2006/relationships" id="263" r:id="R326971873d864e36"/>
-    <p:sldId xmlns:r="http://schemas.openxmlformats.org/officeDocument/2006/relationships" id="264" r:id="R8904d5c1abd6499a"/>
-    <p:sldId xmlns:r="http://schemas.openxmlformats.org/officeDocument/2006/relationships" id="265" r:id="R84ab4e46c5d940e8"/>
-    <p:sldId xmlns:r="http://schemas.openxmlformats.org/officeDocument/2006/relationships" id="266" r:id="Re65e3d6055b242b1"/>
-    <p:sldId xmlns:r="http://schemas.openxmlformats.org/officeDocument/2006/relationships" id="267" r:id="R36015e437ef344a5"/>
-    <p:sldId xmlns:r="http://schemas.openxmlformats.org/officeDocument/2006/relationships" id="268" r:id="R1c73b500f3e14a18"/>
-    <p:sldId xmlns:r="http://schemas.openxmlformats.org/officeDocument/2006/relationships" id="269" r:id="R6bdc6b2f4d7b4439"/>
+    <p:sldId xmlns:r="http://schemas.openxmlformats.org/officeDocument/2006/relationships" id="256" r:id="R7bf620a6d3c1446e"/>
+    <p:sldId xmlns:r="http://schemas.openxmlformats.org/officeDocument/2006/relationships" id="257" r:id="Rab8a740f2692449b"/>
+    <p:sldId xmlns:r="http://schemas.openxmlformats.org/officeDocument/2006/relationships" id="258" r:id="R584622d21f604e0f"/>
+    <p:sldId xmlns:r="http://schemas.openxmlformats.org/officeDocument/2006/relationships" id="259" r:id="Rea2bf2d919b94d39"/>
+    <p:sldId xmlns:r="http://schemas.openxmlformats.org/officeDocument/2006/relationships" id="260" r:id="R2ed6611b96f24343"/>
+    <p:sldId xmlns:r="http://schemas.openxmlformats.org/officeDocument/2006/relationships" id="261" r:id="Rfdbfdde2e15e4cc3"/>
+    <p:sldId xmlns:r="http://schemas.openxmlformats.org/officeDocument/2006/relationships" id="262" r:id="R15e0978d80964b84"/>
+    <p:sldId xmlns:r="http://schemas.openxmlformats.org/officeDocument/2006/relationships" id="263" r:id="R8a679f3a7608476c"/>
+    <p:sldId xmlns:r="http://schemas.openxmlformats.org/officeDocument/2006/relationships" id="264" r:id="Rda09e66684974a47"/>
+    <p:sldId xmlns:r="http://schemas.openxmlformats.org/officeDocument/2006/relationships" id="265" r:id="R6f43c1a494ec4d24"/>
+    <p:sldId xmlns:r="http://schemas.openxmlformats.org/officeDocument/2006/relationships" id="266" r:id="R4f662afd7a9b45bc"/>
+    <p:sldId xmlns:r="http://schemas.openxmlformats.org/officeDocument/2006/relationships" id="267" r:id="R0f2a195a9ae44165"/>
+    <p:sldId xmlns:r="http://schemas.openxmlformats.org/officeDocument/2006/relationships" id="268" r:id="Rd084eeb491be4a3f"/>
+    <p:sldId xmlns:r="http://schemas.openxmlformats.org/officeDocument/2006/relationships" id="269" r:id="R4732bf9f61944041"/>
   </p:sldIdLst>
   <p:sldSz cx="12192000" cy="6858000"/>
   <p:notesSz cx="6858000" cy="9144000"/>
@@ -1448,7 +1448,7 @@
   </p:cSld>
   <p:clrMap bg1="lt1" tx1="dk1" bg2="lt2" tx2="dk2" accent1="accent1" accent2="accent2" accent3="accent3" accent4="accent4" accent5="accent5" accent6="accent6" hlink="hlink" folHlink="folHlink"/>
   <p:sldLayoutIdLst>
-    <p:sldLayoutId xmlns:r="http://schemas.openxmlformats.org/officeDocument/2006/relationships" id="2147483649" r:id="R130ffb1a4e8d443e"/>
+    <p:sldLayoutId xmlns:r="http://schemas.openxmlformats.org/officeDocument/2006/relationships" id="2147483649" r:id="R565d8bb46d3746b4"/>
   </p:sldLayoutIdLst>
   <p:hf sldNum="0" hdr="0" ftr="0" dt="0"/>
   <p:txStyles>
@@ -2001,7 +2001,7 @@
     <p:bg>
       <p:bgPr>
         <a:blipFill xmlns:a="http://schemas.openxmlformats.org/drawingml/2006/main" rotWithShape="1">
-          <a:blip xmlns:r="http://schemas.openxmlformats.org/officeDocument/2006/relationships" r:embed="R785cabba07544524">
+          <a:blip xmlns:r="http://schemas.openxmlformats.org/officeDocument/2006/relationships" r:embed="R3145054622ad4dad">
             <a:lum/>
           </a:blip>
           <a:srcRect l="0" t="0" r="0" b="0"/>
@@ -2029,7 +2029,7 @@
           <p:nvPr/>
         </p:nvPicPr>
         <p:blipFill>
-          <a:blip xmlns:r="http://schemas.openxmlformats.org/officeDocument/2006/relationships" xmlns:a="http://schemas.openxmlformats.org/drawingml/2006/main" r:embed="R2bfac35c3a7543d7"/>
+          <a:blip xmlns:r="http://schemas.openxmlformats.org/officeDocument/2006/relationships" xmlns:a="http://schemas.openxmlformats.org/drawingml/2006/main" r:embed="R202d6d46e7224c6d"/>
           <a:stretch xmlns:a="http://schemas.openxmlformats.org/drawingml/2006/main">
             <a:fillRect l="0" t="0" r="0" b="0"/>
           </a:stretch>
@@ -2053,7 +2053,7 @@
           <p:nvPr/>
         </p:nvPicPr>
         <p:blipFill>
-          <a:blip xmlns:r="http://schemas.openxmlformats.org/officeDocument/2006/relationships" xmlns:a="http://schemas.openxmlformats.org/drawingml/2006/main" r:embed="Reb64ef7be6214068"/>
+          <a:blip xmlns:r="http://schemas.openxmlformats.org/officeDocument/2006/relationships" xmlns:a="http://schemas.openxmlformats.org/drawingml/2006/main" r:embed="R88568a5646ed4b87"/>
           <a:stretch xmlns:a="http://schemas.openxmlformats.org/drawingml/2006/main">
             <a:fillRect l="0" t="0" r="0" b="0"/>
           </a:stretch>
@@ -2642,7 +2642,7 @@
           <p:nvPr/>
         </p:nvPicPr>
         <p:blipFill>
-          <a:blip xmlns:r="http://schemas.openxmlformats.org/officeDocument/2006/relationships" xmlns:a="http://schemas.openxmlformats.org/drawingml/2006/main" r:embed="Rf47ec49b00a3494d"/>
+          <a:blip xmlns:r="http://schemas.openxmlformats.org/officeDocument/2006/relationships" xmlns:a="http://schemas.openxmlformats.org/drawingml/2006/main" r:embed="R4a919790475e45f3"/>
           <a:stretch xmlns:a="http://schemas.openxmlformats.org/drawingml/2006/main">
             <a:fillRect l="0" t="0" r="0" b="0"/>
           </a:stretch>
@@ -2666,7 +2666,7 @@
           <p:nvPr/>
         </p:nvPicPr>
         <p:blipFill>
-          <a:blip xmlns:r="http://schemas.openxmlformats.org/officeDocument/2006/relationships" xmlns:a="http://schemas.openxmlformats.org/drawingml/2006/main" r:embed="R75e23c6148984ddc"/>
+          <a:blip xmlns:r="http://schemas.openxmlformats.org/officeDocument/2006/relationships" xmlns:a="http://schemas.openxmlformats.org/drawingml/2006/main" r:embed="Rf1bf4773e71f46ac"/>
           <a:stretch xmlns:a="http://schemas.openxmlformats.org/drawingml/2006/main">
             <a:fillRect l="0" t="0" r="0" b="0"/>
           </a:stretch>
@@ -3591,7 +3591,7 @@
           <p:nvPr/>
         </p:nvPicPr>
         <p:blipFill>
-          <a:blip xmlns:r="http://schemas.openxmlformats.org/officeDocument/2006/relationships" xmlns:a="http://schemas.openxmlformats.org/drawingml/2006/main" r:embed="Re71bfa562a2c4cba"/>
+          <a:blip xmlns:r="http://schemas.openxmlformats.org/officeDocument/2006/relationships" xmlns:a="http://schemas.openxmlformats.org/drawingml/2006/main" r:embed="R873683db8f374e8f"/>
           <a:stretch xmlns:a="http://schemas.openxmlformats.org/drawingml/2006/main">
             <a:fillRect l="0" t="0" r="0" b="0"/>
           </a:stretch>
@@ -3615,7 +3615,7 @@
           <p:nvPr/>
         </p:nvPicPr>
         <p:blipFill>
-          <a:blip xmlns:r="http://schemas.openxmlformats.org/officeDocument/2006/relationships" xmlns:a="http://schemas.openxmlformats.org/drawingml/2006/main" r:embed="Rbb4c4293d183459d"/>
+          <a:blip xmlns:r="http://schemas.openxmlformats.org/officeDocument/2006/relationships" xmlns:a="http://schemas.openxmlformats.org/drawingml/2006/main" r:embed="Re016579f818b4582"/>
           <a:stretch xmlns:a="http://schemas.openxmlformats.org/drawingml/2006/main">
             <a:fillRect l="0" t="0" r="0" b="0"/>
           </a:stretch>
@@ -3851,7 +3851,7 @@
           <p:nvPr/>
         </p:nvPicPr>
         <p:blipFill>
-          <a:blip xmlns:r="http://schemas.openxmlformats.org/officeDocument/2006/relationships" xmlns:a="http://schemas.openxmlformats.org/drawingml/2006/main" r:embed="R745d74009fd14867"/>
+          <a:blip xmlns:r="http://schemas.openxmlformats.org/officeDocument/2006/relationships" xmlns:a="http://schemas.openxmlformats.org/drawingml/2006/main" r:embed="R65115407e44a4753"/>
           <a:stretch xmlns:a="http://schemas.openxmlformats.org/drawingml/2006/main">
             <a:fillRect l="0" t="0" r="0" b="0"/>
           </a:stretch>
@@ -3928,7 +3928,7 @@
           <p:nvPr/>
         </p:nvPicPr>
         <p:blipFill>
-          <a:blip xmlns:r="http://schemas.openxmlformats.org/officeDocument/2006/relationships" xmlns:a="http://schemas.openxmlformats.org/drawingml/2006/main" r:embed="Rce47d0dab6ec4f88"/>
+          <a:blip xmlns:r="http://schemas.openxmlformats.org/officeDocument/2006/relationships" xmlns:a="http://schemas.openxmlformats.org/drawingml/2006/main" r:embed="R78857a0509f64947"/>
           <a:stretch xmlns:a="http://schemas.openxmlformats.org/drawingml/2006/main">
             <a:fillRect l="0" t="0" r="0" b="0"/>
           </a:stretch>
@@ -4005,7 +4005,7 @@
           <p:nvPr/>
         </p:nvPicPr>
         <p:blipFill>
-          <a:blip xmlns:r="http://schemas.openxmlformats.org/officeDocument/2006/relationships" xmlns:a="http://schemas.openxmlformats.org/drawingml/2006/main" r:embed="R4c0ad221656b4213"/>
+          <a:blip xmlns:r="http://schemas.openxmlformats.org/officeDocument/2006/relationships" xmlns:a="http://schemas.openxmlformats.org/drawingml/2006/main" r:embed="R540c6dc2ab304343"/>
           <a:stretch xmlns:a="http://schemas.openxmlformats.org/drawingml/2006/main">
             <a:fillRect l="0" t="0" r="0" b="0"/>
           </a:stretch>
@@ -4082,7 +4082,7 @@
           <p:nvPr/>
         </p:nvPicPr>
         <p:blipFill>
-          <a:blip xmlns:r="http://schemas.openxmlformats.org/officeDocument/2006/relationships" xmlns:a="http://schemas.openxmlformats.org/drawingml/2006/main" r:embed="Re28909d0332c41d4"/>
+          <a:blip xmlns:r="http://schemas.openxmlformats.org/officeDocument/2006/relationships" xmlns:a="http://schemas.openxmlformats.org/drawingml/2006/main" r:embed="Rf764412e3f6b4c6c"/>
           <a:stretch xmlns:a="http://schemas.openxmlformats.org/drawingml/2006/main">
             <a:fillRect l="0" t="0" r="0" b="0"/>
           </a:stretch>
@@ -4159,7 +4159,7 @@
           <p:nvPr/>
         </p:nvPicPr>
         <p:blipFill>
-          <a:blip xmlns:r="http://schemas.openxmlformats.org/officeDocument/2006/relationships" xmlns:a="http://schemas.openxmlformats.org/drawingml/2006/main" r:embed="R0e27e38e8da64012"/>
+          <a:blip xmlns:r="http://schemas.openxmlformats.org/officeDocument/2006/relationships" xmlns:a="http://schemas.openxmlformats.org/drawingml/2006/main" r:embed="R3bb2dcbec55e4565"/>
           <a:stretch xmlns:a="http://schemas.openxmlformats.org/drawingml/2006/main">
             <a:fillRect l="0" t="0" r="0" b="0"/>
           </a:stretch>
@@ -4236,7 +4236,7 @@
           <p:nvPr/>
         </p:nvPicPr>
         <p:blipFill>
-          <a:blip xmlns:r="http://schemas.openxmlformats.org/officeDocument/2006/relationships" xmlns:a="http://schemas.openxmlformats.org/drawingml/2006/main" r:embed="Rf4b0f0f1b8244b39"/>
+          <a:blip xmlns:r="http://schemas.openxmlformats.org/officeDocument/2006/relationships" xmlns:a="http://schemas.openxmlformats.org/drawingml/2006/main" r:embed="Rbe1d4637b7f34f93"/>
           <a:stretch xmlns:a="http://schemas.openxmlformats.org/drawingml/2006/main">
             <a:fillRect l="0" t="0" r="0" b="0"/>
           </a:stretch>
@@ -4313,7 +4313,7 @@
           <p:nvPr/>
         </p:nvPicPr>
         <p:blipFill>
-          <a:blip xmlns:r="http://schemas.openxmlformats.org/officeDocument/2006/relationships" xmlns:a="http://schemas.openxmlformats.org/drawingml/2006/main" r:embed="R64cec8f873f9491b"/>
+          <a:blip xmlns:r="http://schemas.openxmlformats.org/officeDocument/2006/relationships" xmlns:a="http://schemas.openxmlformats.org/drawingml/2006/main" r:embed="R1323e856edb24dc6"/>
           <a:stretch xmlns:a="http://schemas.openxmlformats.org/drawingml/2006/main">
             <a:fillRect l="0" t="0" r="0" b="0"/>
           </a:stretch>
@@ -4603,7 +4603,7 @@
           <p:nvPr/>
         </p:nvPicPr>
         <p:blipFill>
-          <a:blip xmlns:r="http://schemas.openxmlformats.org/officeDocument/2006/relationships" xmlns:a="http://schemas.openxmlformats.org/drawingml/2006/main" r:embed="Rd9a313f0ad8b4f82"/>
+          <a:blip xmlns:r="http://schemas.openxmlformats.org/officeDocument/2006/relationships" xmlns:a="http://schemas.openxmlformats.org/drawingml/2006/main" r:embed="R05640878d6ff4d6f"/>
           <a:stretch xmlns:a="http://schemas.openxmlformats.org/drawingml/2006/main">
             <a:fillRect l="0" t="0" r="0" b="0"/>
           </a:stretch>
@@ -4786,7 +4786,7 @@
           <p:nvPr/>
         </p:nvPicPr>
         <p:blipFill>
-          <a:blip xmlns:r="http://schemas.openxmlformats.org/officeDocument/2006/relationships" xmlns:a="http://schemas.openxmlformats.org/drawingml/2006/main" r:embed="R9d7516176fea4eec"/>
+          <a:blip xmlns:r="http://schemas.openxmlformats.org/officeDocument/2006/relationships" xmlns:a="http://schemas.openxmlformats.org/drawingml/2006/main" r:embed="R3df2981705bd465b"/>
           <a:stretch xmlns:a="http://schemas.openxmlformats.org/drawingml/2006/main">
             <a:fillRect l="0" t="0" r="0" b="0"/>
           </a:stretch>
@@ -4810,7 +4810,7 @@
           <p:nvPr/>
         </p:nvPicPr>
         <p:blipFill>
-          <a:blip xmlns:r="http://schemas.openxmlformats.org/officeDocument/2006/relationships" xmlns:a="http://schemas.openxmlformats.org/drawingml/2006/main" r:embed="R2a406a67ea274baa"/>
+          <a:blip xmlns:r="http://schemas.openxmlformats.org/officeDocument/2006/relationships" xmlns:a="http://schemas.openxmlformats.org/drawingml/2006/main" r:embed="R942b04f82d7049dd"/>
           <a:stretch xmlns:a="http://schemas.openxmlformats.org/drawingml/2006/main">
             <a:fillRect l="0" t="0" r="0" b="0"/>
           </a:stretch>
@@ -5046,7 +5046,7 @@
           <p:nvPr/>
         </p:nvPicPr>
         <p:blipFill>
-          <a:blip xmlns:r="http://schemas.openxmlformats.org/officeDocument/2006/relationships" xmlns:a="http://schemas.openxmlformats.org/drawingml/2006/main" r:embed="R491f84be09d24850"/>
+          <a:blip xmlns:r="http://schemas.openxmlformats.org/officeDocument/2006/relationships" xmlns:a="http://schemas.openxmlformats.org/drawingml/2006/main" r:embed="R29e55e0f92ab44a0"/>
           <a:stretch xmlns:a="http://schemas.openxmlformats.org/drawingml/2006/main">
             <a:fillRect l="0" t="0" r="0" b="0"/>
           </a:stretch>
@@ -5123,7 +5123,7 @@
           <p:nvPr/>
         </p:nvPicPr>
         <p:blipFill>
-          <a:blip xmlns:r="http://schemas.openxmlformats.org/officeDocument/2006/relationships" xmlns:a="http://schemas.openxmlformats.org/drawingml/2006/main" r:embed="R94c50ad057634f0f"/>
+          <a:blip xmlns:r="http://schemas.openxmlformats.org/officeDocument/2006/relationships" xmlns:a="http://schemas.openxmlformats.org/drawingml/2006/main" r:embed="R63d92830610c4f46"/>
           <a:stretch xmlns:a="http://schemas.openxmlformats.org/drawingml/2006/main">
             <a:fillRect l="0" t="0" r="0" b="0"/>
           </a:stretch>
@@ -5200,7 +5200,7 @@
           <p:nvPr/>
         </p:nvPicPr>
         <p:blipFill>
-          <a:blip xmlns:r="http://schemas.openxmlformats.org/officeDocument/2006/relationships" xmlns:a="http://schemas.openxmlformats.org/drawingml/2006/main" r:embed="Ra1d2e6777c8948ac"/>
+          <a:blip xmlns:r="http://schemas.openxmlformats.org/officeDocument/2006/relationships" xmlns:a="http://schemas.openxmlformats.org/drawingml/2006/main" r:embed="R26319407fae941ee"/>
           <a:stretch xmlns:a="http://schemas.openxmlformats.org/drawingml/2006/main">
             <a:fillRect l="0" t="0" r="0" b="0"/>
           </a:stretch>
@@ -5277,7 +5277,7 @@
           <p:nvPr/>
         </p:nvPicPr>
         <p:blipFill>
-          <a:blip xmlns:r="http://schemas.openxmlformats.org/officeDocument/2006/relationships" xmlns:a="http://schemas.openxmlformats.org/drawingml/2006/main" r:embed="R97b9d1bcd9074b78"/>
+          <a:blip xmlns:r="http://schemas.openxmlformats.org/officeDocument/2006/relationships" xmlns:a="http://schemas.openxmlformats.org/drawingml/2006/main" r:embed="R42ae25ae4b22418e"/>
           <a:stretch xmlns:a="http://schemas.openxmlformats.org/drawingml/2006/main">
             <a:fillRect l="0" t="0" r="0" b="0"/>
           </a:stretch>
@@ -5354,7 +5354,7 @@
           <p:nvPr/>
         </p:nvPicPr>
         <p:blipFill>
-          <a:blip xmlns:r="http://schemas.openxmlformats.org/officeDocument/2006/relationships" xmlns:a="http://schemas.openxmlformats.org/drawingml/2006/main" r:embed="Reb5b7f1aacb04eaa"/>
+          <a:blip xmlns:r="http://schemas.openxmlformats.org/officeDocument/2006/relationships" xmlns:a="http://schemas.openxmlformats.org/drawingml/2006/main" r:embed="R8762ba2950bb4bfd"/>
           <a:stretch xmlns:a="http://schemas.openxmlformats.org/drawingml/2006/main">
             <a:fillRect l="0" t="0" r="0" b="0"/>
           </a:stretch>
@@ -5431,7 +5431,7 @@
           <p:nvPr/>
         </p:nvPicPr>
         <p:blipFill>
-          <a:blip xmlns:r="http://schemas.openxmlformats.org/officeDocument/2006/relationships" xmlns:a="http://schemas.openxmlformats.org/drawingml/2006/main" r:embed="Rc5f0a1b623b64476"/>
+          <a:blip xmlns:r="http://schemas.openxmlformats.org/officeDocument/2006/relationships" xmlns:a="http://schemas.openxmlformats.org/drawingml/2006/main" r:embed="R281052957ed74456"/>
           <a:stretch xmlns:a="http://schemas.openxmlformats.org/drawingml/2006/main">
             <a:fillRect l="0" t="0" r="0" b="0"/>
           </a:stretch>
@@ -5508,7 +5508,7 @@
           <p:nvPr/>
         </p:nvPicPr>
         <p:blipFill>
-          <a:blip xmlns:r="http://schemas.openxmlformats.org/officeDocument/2006/relationships" xmlns:a="http://schemas.openxmlformats.org/drawingml/2006/main" r:embed="R0cb5a8f6f8924e27"/>
+          <a:blip xmlns:r="http://schemas.openxmlformats.org/officeDocument/2006/relationships" xmlns:a="http://schemas.openxmlformats.org/drawingml/2006/main" r:embed="R3d1e0a4eef374a4b"/>
           <a:stretch xmlns:a="http://schemas.openxmlformats.org/drawingml/2006/main">
             <a:fillRect l="0" t="0" r="0" b="0"/>
           </a:stretch>
@@ -5798,7 +5798,7 @@
           <p:nvPr/>
         </p:nvPicPr>
         <p:blipFill>
-          <a:blip xmlns:r="http://schemas.openxmlformats.org/officeDocument/2006/relationships" xmlns:a="http://schemas.openxmlformats.org/drawingml/2006/main" r:embed="Rc5a45a3284524880"/>
+          <a:blip xmlns:r="http://schemas.openxmlformats.org/officeDocument/2006/relationships" xmlns:a="http://schemas.openxmlformats.org/drawingml/2006/main" r:embed="Rd3c1069b755b4704"/>
           <a:stretch xmlns:a="http://schemas.openxmlformats.org/drawingml/2006/main">
             <a:fillRect l="0" t="0" r="0" b="0"/>
           </a:stretch>
@@ -5981,7 +5981,7 @@
           <p:nvPr/>
         </p:nvPicPr>
         <p:blipFill>
-          <a:blip xmlns:r="http://schemas.openxmlformats.org/officeDocument/2006/relationships" xmlns:a="http://schemas.openxmlformats.org/drawingml/2006/main" r:embed="Rf87a915d60104a50"/>
+          <a:blip xmlns:r="http://schemas.openxmlformats.org/officeDocument/2006/relationships" xmlns:a="http://schemas.openxmlformats.org/drawingml/2006/main" r:embed="R402caccedafe46c4"/>
           <a:stretch xmlns:a="http://schemas.openxmlformats.org/drawingml/2006/main">
             <a:fillRect l="0" t="0" r="0" b="0"/>
           </a:stretch>
@@ -6005,7 +6005,7 @@
           <p:nvPr/>
         </p:nvPicPr>
         <p:blipFill>
-          <a:blip xmlns:r="http://schemas.openxmlformats.org/officeDocument/2006/relationships" xmlns:a="http://schemas.openxmlformats.org/drawingml/2006/main" r:embed="Rf5adf79ee5f04a80"/>
+          <a:blip xmlns:r="http://schemas.openxmlformats.org/officeDocument/2006/relationships" xmlns:a="http://schemas.openxmlformats.org/drawingml/2006/main" r:embed="R740ace5809aa43c3"/>
           <a:stretch xmlns:a="http://schemas.openxmlformats.org/drawingml/2006/main">
             <a:fillRect l="0" t="0" r="0" b="0"/>
           </a:stretch>
@@ -6924,7 +6924,7 @@
           <p:nvPr/>
         </p:nvPicPr>
         <p:blipFill>
-          <a:blip xmlns:r="http://schemas.openxmlformats.org/officeDocument/2006/relationships" xmlns:a="http://schemas.openxmlformats.org/drawingml/2006/main" r:embed="R5d67924568f04b68"/>
+          <a:blip xmlns:r="http://schemas.openxmlformats.org/officeDocument/2006/relationships" xmlns:a="http://schemas.openxmlformats.org/drawingml/2006/main" r:embed="Rd16680b9a6c24cd9"/>
           <a:stretch xmlns:a="http://schemas.openxmlformats.org/drawingml/2006/main">
             <a:fillRect l="0" t="0" r="0" b="0"/>
           </a:stretch>
@@ -6948,7 +6948,7 @@
           <p:nvPr/>
         </p:nvPicPr>
         <p:blipFill>
-          <a:blip xmlns:r="http://schemas.openxmlformats.org/officeDocument/2006/relationships" xmlns:a="http://schemas.openxmlformats.org/drawingml/2006/main" r:embed="R8d5e3825a89b49cc"/>
+          <a:blip xmlns:r="http://schemas.openxmlformats.org/officeDocument/2006/relationships" xmlns:a="http://schemas.openxmlformats.org/drawingml/2006/main" r:embed="Rd74484ac882842e3"/>
           <a:stretch xmlns:a="http://schemas.openxmlformats.org/drawingml/2006/main">
             <a:fillRect l="0" t="0" r="0" b="0"/>
           </a:stretch>
@@ -7184,7 +7184,7 @@
           <p:nvPr/>
         </p:nvPicPr>
         <p:blipFill>
-          <a:blip xmlns:r="http://schemas.openxmlformats.org/officeDocument/2006/relationships" xmlns:a="http://schemas.openxmlformats.org/drawingml/2006/main" r:embed="R15d1bca4f61c486e"/>
+          <a:blip xmlns:r="http://schemas.openxmlformats.org/officeDocument/2006/relationships" xmlns:a="http://schemas.openxmlformats.org/drawingml/2006/main" r:embed="R1c0379fa7d3b45f3"/>
           <a:stretch xmlns:a="http://schemas.openxmlformats.org/drawingml/2006/main">
             <a:fillRect l="0" t="0" r="0" b="0"/>
           </a:stretch>
@@ -7261,7 +7261,7 @@
           <p:nvPr/>
         </p:nvPicPr>
         <p:blipFill>
-          <a:blip xmlns:r="http://schemas.openxmlformats.org/officeDocument/2006/relationships" xmlns:a="http://schemas.openxmlformats.org/drawingml/2006/main" r:embed="R6640bde1ac874048"/>
+          <a:blip xmlns:r="http://schemas.openxmlformats.org/officeDocument/2006/relationships" xmlns:a="http://schemas.openxmlformats.org/drawingml/2006/main" r:embed="Rd1e8b9e842674ab4"/>
           <a:stretch xmlns:a="http://schemas.openxmlformats.org/drawingml/2006/main">
             <a:fillRect l="0" t="0" r="0" b="0"/>
           </a:stretch>
@@ -7338,7 +7338,7 @@
           <p:nvPr/>
         </p:nvPicPr>
         <p:blipFill>
-          <a:blip xmlns:r="http://schemas.openxmlformats.org/officeDocument/2006/relationships" xmlns:a="http://schemas.openxmlformats.org/drawingml/2006/main" r:embed="R0504b879374940c5"/>
+          <a:blip xmlns:r="http://schemas.openxmlformats.org/officeDocument/2006/relationships" xmlns:a="http://schemas.openxmlformats.org/drawingml/2006/main" r:embed="R37d7481c2c1c46c2"/>
           <a:stretch xmlns:a="http://schemas.openxmlformats.org/drawingml/2006/main">
             <a:fillRect l="0" t="0" r="0" b="0"/>
           </a:stretch>
@@ -7415,7 +7415,7 @@
           <p:nvPr/>
         </p:nvPicPr>
         <p:blipFill>
-          <a:blip xmlns:r="http://schemas.openxmlformats.org/officeDocument/2006/relationships" xmlns:a="http://schemas.openxmlformats.org/drawingml/2006/main" r:embed="R1ac7231d794c41a5"/>
+          <a:blip xmlns:r="http://schemas.openxmlformats.org/officeDocument/2006/relationships" xmlns:a="http://schemas.openxmlformats.org/drawingml/2006/main" r:embed="R02c2b0576f974b05"/>
           <a:stretch xmlns:a="http://schemas.openxmlformats.org/drawingml/2006/main">
             <a:fillRect l="0" t="0" r="0" b="0"/>
           </a:stretch>
@@ -7492,7 +7492,7 @@
           <p:nvPr/>
         </p:nvPicPr>
         <p:blipFill>
-          <a:blip xmlns:r="http://schemas.openxmlformats.org/officeDocument/2006/relationships" xmlns:a="http://schemas.openxmlformats.org/drawingml/2006/main" r:embed="R3dc457396c8f422d"/>
+          <a:blip xmlns:r="http://schemas.openxmlformats.org/officeDocument/2006/relationships" xmlns:a="http://schemas.openxmlformats.org/drawingml/2006/main" r:embed="R89e24e31fde44500"/>
           <a:stretch xmlns:a="http://schemas.openxmlformats.org/drawingml/2006/main">
             <a:fillRect l="0" t="0" r="0" b="0"/>
           </a:stretch>
@@ -7569,7 +7569,7 @@
           <p:nvPr/>
         </p:nvPicPr>
         <p:blipFill>
-          <a:blip xmlns:r="http://schemas.openxmlformats.org/officeDocument/2006/relationships" xmlns:a="http://schemas.openxmlformats.org/drawingml/2006/main" r:embed="Ra75827bf683e4b2a"/>
+          <a:blip xmlns:r="http://schemas.openxmlformats.org/officeDocument/2006/relationships" xmlns:a="http://schemas.openxmlformats.org/drawingml/2006/main" r:embed="R7a5bc01740164e46"/>
           <a:stretch xmlns:a="http://schemas.openxmlformats.org/drawingml/2006/main">
             <a:fillRect l="0" t="0" r="0" b="0"/>
           </a:stretch>
@@ -7646,7 +7646,7 @@
           <p:nvPr/>
         </p:nvPicPr>
         <p:blipFill>
-          <a:blip xmlns:r="http://schemas.openxmlformats.org/officeDocument/2006/relationships" xmlns:a="http://schemas.openxmlformats.org/drawingml/2006/main" r:embed="R82652cdb308c4a6c"/>
+          <a:blip xmlns:r="http://schemas.openxmlformats.org/officeDocument/2006/relationships" xmlns:a="http://schemas.openxmlformats.org/drawingml/2006/main" r:embed="R96e9afcf0faa461a"/>
           <a:stretch xmlns:a="http://schemas.openxmlformats.org/drawingml/2006/main">
             <a:fillRect l="0" t="0" r="0" b="0"/>
           </a:stretch>
@@ -7936,7 +7936,7 @@
           <p:nvPr/>
         </p:nvPicPr>
         <p:blipFill>
-          <a:blip xmlns:r="http://schemas.openxmlformats.org/officeDocument/2006/relationships" xmlns:a="http://schemas.openxmlformats.org/drawingml/2006/main" r:embed="Rca5287638bc94931"/>
+          <a:blip xmlns:r="http://schemas.openxmlformats.org/officeDocument/2006/relationships" xmlns:a="http://schemas.openxmlformats.org/drawingml/2006/main" r:embed="Rfa7e48f31a28443b"/>
           <a:stretch xmlns:a="http://schemas.openxmlformats.org/drawingml/2006/main">
             <a:fillRect l="0" t="0" r="0" b="0"/>
           </a:stretch>
@@ -8119,7 +8119,7 @@
           <p:nvPr/>
         </p:nvPicPr>
         <p:blipFill>
-          <a:blip xmlns:r="http://schemas.openxmlformats.org/officeDocument/2006/relationships" xmlns:a="http://schemas.openxmlformats.org/drawingml/2006/main" r:embed="R9f013f5c59e240d0"/>
+          <a:blip xmlns:r="http://schemas.openxmlformats.org/officeDocument/2006/relationships" xmlns:a="http://schemas.openxmlformats.org/drawingml/2006/main" r:embed="R5ae7e576a99a416e"/>
           <a:stretch xmlns:a="http://schemas.openxmlformats.org/drawingml/2006/main">
             <a:fillRect l="0" t="0" r="0" b="0"/>
           </a:stretch>
@@ -8143,7 +8143,7 @@
           <p:nvPr/>
         </p:nvPicPr>
         <p:blipFill>
-          <a:blip xmlns:r="http://schemas.openxmlformats.org/officeDocument/2006/relationships" xmlns:a="http://schemas.openxmlformats.org/drawingml/2006/main" r:embed="R09eb3e8d6554465c"/>
+          <a:blip xmlns:r="http://schemas.openxmlformats.org/officeDocument/2006/relationships" xmlns:a="http://schemas.openxmlformats.org/drawingml/2006/main" r:embed="Rb9324eb85f3244ee"/>
           <a:stretch xmlns:a="http://schemas.openxmlformats.org/drawingml/2006/main">
             <a:fillRect l="0" t="0" r="0" b="0"/>
           </a:stretch>
@@ -8408,7 +8408,7 @@
           <p:nvPr/>
         </p:nvPicPr>
         <p:blipFill>
-          <a:blip xmlns:r="http://schemas.openxmlformats.org/officeDocument/2006/relationships" xmlns:a="http://schemas.openxmlformats.org/drawingml/2006/main" r:embed="R987455a2f58b4701"/>
+          <a:blip xmlns:r="http://schemas.openxmlformats.org/officeDocument/2006/relationships" xmlns:a="http://schemas.openxmlformats.org/drawingml/2006/main" r:embed="Rb2492a97c0ad4e53"/>
           <a:stretch xmlns:a="http://schemas.openxmlformats.org/drawingml/2006/main">
             <a:fillRect l="0" t="0" r="0" b="0"/>
           </a:stretch>
@@ -8478,7 +8478,7 @@
           <p:nvPr/>
         </p:nvPicPr>
         <p:blipFill>
-          <a:blip xmlns:r="http://schemas.openxmlformats.org/officeDocument/2006/relationships" xmlns:a="http://schemas.openxmlformats.org/drawingml/2006/main" r:embed="Rd751d0fc04d74ca2"/>
+          <a:blip xmlns:r="http://schemas.openxmlformats.org/officeDocument/2006/relationships" xmlns:a="http://schemas.openxmlformats.org/drawingml/2006/main" r:embed="R9b28e502b06f4b1f"/>
           <a:stretch xmlns:a="http://schemas.openxmlformats.org/drawingml/2006/main">
             <a:fillRect l="0" t="0" r="0" b="0"/>
           </a:stretch>
@@ -8548,7 +8548,7 @@
           <p:nvPr/>
         </p:nvPicPr>
         <p:blipFill>
-          <a:blip xmlns:r="http://schemas.openxmlformats.org/officeDocument/2006/relationships" xmlns:a="http://schemas.openxmlformats.org/drawingml/2006/main" r:embed="R953534f01cf34bb4"/>
+          <a:blip xmlns:r="http://schemas.openxmlformats.org/officeDocument/2006/relationships" xmlns:a="http://schemas.openxmlformats.org/drawingml/2006/main" r:embed="R2d1882f81acd4dc8"/>
           <a:stretch xmlns:a="http://schemas.openxmlformats.org/drawingml/2006/main">
             <a:fillRect l="0" t="0" r="0" b="0"/>
           </a:stretch>
@@ -8618,7 +8618,7 @@
           <p:nvPr/>
         </p:nvPicPr>
         <p:blipFill>
-          <a:blip xmlns:r="http://schemas.openxmlformats.org/officeDocument/2006/relationships" xmlns:a="http://schemas.openxmlformats.org/drawingml/2006/main" r:embed="Rcaac6f55c6bb4bea"/>
+          <a:blip xmlns:r="http://schemas.openxmlformats.org/officeDocument/2006/relationships" xmlns:a="http://schemas.openxmlformats.org/drawingml/2006/main" r:embed="Rb141e6e0d5af427a"/>
           <a:stretch xmlns:a="http://schemas.openxmlformats.org/drawingml/2006/main">
             <a:fillRect l="0" t="0" r="0" b="0"/>
           </a:stretch>
@@ -8688,7 +8688,7 @@
           <p:nvPr/>
         </p:nvPicPr>
         <p:blipFill>
-          <a:blip xmlns:r="http://schemas.openxmlformats.org/officeDocument/2006/relationships" xmlns:a="http://schemas.openxmlformats.org/drawingml/2006/main" r:embed="R50cdd5c76fb948e2"/>
+          <a:blip xmlns:r="http://schemas.openxmlformats.org/officeDocument/2006/relationships" xmlns:a="http://schemas.openxmlformats.org/drawingml/2006/main" r:embed="Rdd23bac2774643e4"/>
           <a:stretch xmlns:a="http://schemas.openxmlformats.org/drawingml/2006/main">
             <a:fillRect l="0" t="0" r="0" b="0"/>
           </a:stretch>
@@ -8758,7 +8758,7 @@
           <p:nvPr/>
         </p:nvPicPr>
         <p:blipFill>
-          <a:blip xmlns:r="http://schemas.openxmlformats.org/officeDocument/2006/relationships" xmlns:a="http://schemas.openxmlformats.org/drawingml/2006/main" r:embed="R5be25f8f16084d8f"/>
+          <a:blip xmlns:r="http://schemas.openxmlformats.org/officeDocument/2006/relationships" xmlns:a="http://schemas.openxmlformats.org/drawingml/2006/main" r:embed="R2ef993edb1b74c02"/>
           <a:stretch xmlns:a="http://schemas.openxmlformats.org/drawingml/2006/main">
             <a:fillRect l="0" t="0" r="0" b="0"/>
           </a:stretch>
@@ -8828,7 +8828,7 @@
           <p:nvPr/>
         </p:nvPicPr>
         <p:blipFill>
-          <a:blip xmlns:r="http://schemas.openxmlformats.org/officeDocument/2006/relationships" xmlns:a="http://schemas.openxmlformats.org/drawingml/2006/main" r:embed="R761302c768b749dc"/>
+          <a:blip xmlns:r="http://schemas.openxmlformats.org/officeDocument/2006/relationships" xmlns:a="http://schemas.openxmlformats.org/drawingml/2006/main" r:embed="Rf1e80d4013544d6b"/>
           <a:stretch xmlns:a="http://schemas.openxmlformats.org/drawingml/2006/main">
             <a:fillRect l="0" t="0" r="0" b="0"/>
           </a:stretch>
@@ -8967,7 +8967,7 @@
                 <a:ea typeface="Calibri"/>
                 <a:cs typeface="Calibri"/>
               </a:rPr>
-              <a:t>BUKTI YANG DIKUMPULKAN</a:t>
+              <a:t>PROYEK KELOMPOK</a:t>
             </a:r>
           </a:p>
           <a:p xmlns:a="http://schemas.openxmlformats.org/drawingml/2006/main">
@@ -8996,7 +8996,7 @@
                 <a:ea typeface="Calibri"/>
                 <a:cs typeface="Calibri"/>
               </a:rPr>
-              <a:t>Hasil mesin sendiri</a:t>
+              <a:t>Tim 3 orang</a:t>
             </a:r>
             <a:endParaRPr sz="1100"/>
           </a:p>
@@ -9045,7 +9045,7 @@
                 <a:ea typeface="Calibri"/>
                 <a:cs typeface="Calibri"/>
               </a:rPr>
-              <a:t>1. Bukti training dan UI Gradio</a:t>
+              <a:t>Model kecil memberi baseline proyek</a:t>
             </a:r>
           </a:p>
           <a:p xmlns:a="http://schemas.openxmlformats.org/drawingml/2006/main">
@@ -9064,7 +9064,7 @@
                 <a:ea typeface="Calibri"/>
                 <a:cs typeface="Calibri"/>
               </a:rPr>
-              <a:t>2. Positif, negatif, input kosong</a:t>
+              <a:t>Evaluasi hasil dan batas data</a:t>
             </a:r>
           </a:p>
           <a:p xmlns:a="http://schemas.openxmlformats.org/drawingml/2006/main">
@@ -9083,7 +9083,7 @@
                 <a:ea typeface="Calibri"/>
                 <a:cs typeface="Calibri"/>
               </a:rPr>
-              <a:t>3. Pengaruh ambang dan token</a:t>
+              <a:t>Simpan bukti bila berguna</a:t>
             </a:r>
           </a:p>
           <a:p xmlns:a="http://schemas.openxmlformats.org/drawingml/2006/main">
@@ -9102,7 +9102,7 @@
                 <a:ea typeface="Calibri"/>
                 <a:cs typeface="Calibri"/>
               </a:rPr>
-              <a:t>4. Source Git tanpa token/cache</a:t>
+              <a:t>Minggu 7 dan 14; tanpa nilai Lab 09</a:t>
             </a:r>
             <a:endParaRPr sz="1700"/>
           </a:p>
@@ -9360,7 +9360,7 @@
           <p:nvPr/>
         </p:nvPicPr>
         <p:blipFill>
-          <a:blip xmlns:r="http://schemas.openxmlformats.org/officeDocument/2006/relationships" xmlns:a="http://schemas.openxmlformats.org/drawingml/2006/main" r:embed="R37f3c0a5b50c4498"/>
+          <a:blip xmlns:r="http://schemas.openxmlformats.org/officeDocument/2006/relationships" xmlns:a="http://schemas.openxmlformats.org/drawingml/2006/main" r:embed="R8792447b736843db"/>
           <a:stretch xmlns:a="http://schemas.openxmlformats.org/drawingml/2006/main">
             <a:fillRect l="0" t="0" r="0" b="0"/>
           </a:stretch>
@@ -9384,7 +9384,7 @@
           <p:nvPr/>
         </p:nvPicPr>
         <p:blipFill>
-          <a:blip xmlns:r="http://schemas.openxmlformats.org/officeDocument/2006/relationships" xmlns:a="http://schemas.openxmlformats.org/drawingml/2006/main" r:embed="R4776b94fc77b4c47"/>
+          <a:blip xmlns:r="http://schemas.openxmlformats.org/officeDocument/2006/relationships" xmlns:a="http://schemas.openxmlformats.org/drawingml/2006/main" r:embed="Raf825efa6be14cb0"/>
           <a:stretch xmlns:a="http://schemas.openxmlformats.org/drawingml/2006/main">
             <a:fillRect l="0" t="0" r="0" b="0"/>
           </a:stretch>
@@ -10308,7 +10308,7 @@
           <p:nvPr/>
         </p:nvPicPr>
         <p:blipFill>
-          <a:blip xmlns:r="http://schemas.openxmlformats.org/officeDocument/2006/relationships" xmlns:a="http://schemas.openxmlformats.org/drawingml/2006/main" r:embed="Re3e4bc56a8aa4917"/>
+          <a:blip xmlns:r="http://schemas.openxmlformats.org/officeDocument/2006/relationships" xmlns:a="http://schemas.openxmlformats.org/drawingml/2006/main" r:embed="R8ab35237014f43d2"/>
           <a:stretch xmlns:a="http://schemas.openxmlformats.org/drawingml/2006/main">
             <a:fillRect l="0" t="0" r="0" b="0"/>
           </a:stretch>
@@ -10332,7 +10332,7 @@
           <p:nvPr/>
         </p:nvPicPr>
         <p:blipFill>
-          <a:blip xmlns:r="http://schemas.openxmlformats.org/officeDocument/2006/relationships" xmlns:a="http://schemas.openxmlformats.org/drawingml/2006/main" r:embed="R7caed870ae4c4645"/>
+          <a:blip xmlns:r="http://schemas.openxmlformats.org/officeDocument/2006/relationships" xmlns:a="http://schemas.openxmlformats.org/drawingml/2006/main" r:embed="R684b7b5ba69a476f"/>
           <a:stretch xmlns:a="http://schemas.openxmlformats.org/drawingml/2006/main">
             <a:fillRect l="0" t="0" r="0" b="0"/>
           </a:stretch>
@@ -10568,7 +10568,7 @@
           <p:nvPr/>
         </p:nvPicPr>
         <p:blipFill>
-          <a:blip xmlns:r="http://schemas.openxmlformats.org/officeDocument/2006/relationships" xmlns:a="http://schemas.openxmlformats.org/drawingml/2006/main" r:embed="R0f34c87a2ddf49b7"/>
+          <a:blip xmlns:r="http://schemas.openxmlformats.org/officeDocument/2006/relationships" xmlns:a="http://schemas.openxmlformats.org/drawingml/2006/main" r:embed="Re454b8828a7d46bc"/>
           <a:stretch xmlns:a="http://schemas.openxmlformats.org/drawingml/2006/main">
             <a:fillRect l="0" t="0" r="0" b="0"/>
           </a:stretch>
@@ -10645,7 +10645,7 @@
           <p:nvPr/>
         </p:nvPicPr>
         <p:blipFill>
-          <a:blip xmlns:r="http://schemas.openxmlformats.org/officeDocument/2006/relationships" xmlns:a="http://schemas.openxmlformats.org/drawingml/2006/main" r:embed="R955b32e0706d4304"/>
+          <a:blip xmlns:r="http://schemas.openxmlformats.org/officeDocument/2006/relationships" xmlns:a="http://schemas.openxmlformats.org/drawingml/2006/main" r:embed="Rd9e997e25b7f4b50"/>
           <a:stretch xmlns:a="http://schemas.openxmlformats.org/drawingml/2006/main">
             <a:fillRect l="0" t="0" r="0" b="0"/>
           </a:stretch>
@@ -10722,7 +10722,7 @@
           <p:nvPr/>
         </p:nvPicPr>
         <p:blipFill>
-          <a:blip xmlns:r="http://schemas.openxmlformats.org/officeDocument/2006/relationships" xmlns:a="http://schemas.openxmlformats.org/drawingml/2006/main" r:embed="R17d63acbe02647a7"/>
+          <a:blip xmlns:r="http://schemas.openxmlformats.org/officeDocument/2006/relationships" xmlns:a="http://schemas.openxmlformats.org/drawingml/2006/main" r:embed="R46948f8b51af4f90"/>
           <a:stretch xmlns:a="http://schemas.openxmlformats.org/drawingml/2006/main">
             <a:fillRect l="0" t="0" r="0" b="0"/>
           </a:stretch>
@@ -10799,7 +10799,7 @@
           <p:nvPr/>
         </p:nvPicPr>
         <p:blipFill>
-          <a:blip xmlns:r="http://schemas.openxmlformats.org/officeDocument/2006/relationships" xmlns:a="http://schemas.openxmlformats.org/drawingml/2006/main" r:embed="Rf88239e8f1a548e3"/>
+          <a:blip xmlns:r="http://schemas.openxmlformats.org/officeDocument/2006/relationships" xmlns:a="http://schemas.openxmlformats.org/drawingml/2006/main" r:embed="R654fc69b6d764f5b"/>
           <a:stretch xmlns:a="http://schemas.openxmlformats.org/drawingml/2006/main">
             <a:fillRect l="0" t="0" r="0" b="0"/>
           </a:stretch>
@@ -10876,7 +10876,7 @@
           <p:nvPr/>
         </p:nvPicPr>
         <p:blipFill>
-          <a:blip xmlns:r="http://schemas.openxmlformats.org/officeDocument/2006/relationships" xmlns:a="http://schemas.openxmlformats.org/drawingml/2006/main" r:embed="Rf9fff752c66d4ba8"/>
+          <a:blip xmlns:r="http://schemas.openxmlformats.org/officeDocument/2006/relationships" xmlns:a="http://schemas.openxmlformats.org/drawingml/2006/main" r:embed="Rc6782d050a4d412f"/>
           <a:stretch xmlns:a="http://schemas.openxmlformats.org/drawingml/2006/main">
             <a:fillRect l="0" t="0" r="0" b="0"/>
           </a:stretch>
@@ -10953,7 +10953,7 @@
           <p:nvPr/>
         </p:nvPicPr>
         <p:blipFill>
-          <a:blip xmlns:r="http://schemas.openxmlformats.org/officeDocument/2006/relationships" xmlns:a="http://schemas.openxmlformats.org/drawingml/2006/main" r:embed="R9cb9ba783da24686"/>
+          <a:blip xmlns:r="http://schemas.openxmlformats.org/officeDocument/2006/relationships" xmlns:a="http://schemas.openxmlformats.org/drawingml/2006/main" r:embed="R3681dc28289944ee"/>
           <a:stretch xmlns:a="http://schemas.openxmlformats.org/drawingml/2006/main">
             <a:fillRect l="0" t="0" r="0" b="0"/>
           </a:stretch>
@@ -11030,7 +11030,7 @@
           <p:nvPr/>
         </p:nvPicPr>
         <p:blipFill>
-          <a:blip xmlns:r="http://schemas.openxmlformats.org/officeDocument/2006/relationships" xmlns:a="http://schemas.openxmlformats.org/drawingml/2006/main" r:embed="R3ce4ea45c2254ba7"/>
+          <a:blip xmlns:r="http://schemas.openxmlformats.org/officeDocument/2006/relationships" xmlns:a="http://schemas.openxmlformats.org/drawingml/2006/main" r:embed="R5879984ed0774668"/>
           <a:stretch xmlns:a="http://schemas.openxmlformats.org/drawingml/2006/main">
             <a:fillRect l="0" t="0" r="0" b="0"/>
           </a:stretch>
@@ -11320,7 +11320,7 @@
           <p:nvPr/>
         </p:nvPicPr>
         <p:blipFill>
-          <a:blip xmlns:r="http://schemas.openxmlformats.org/officeDocument/2006/relationships" xmlns:a="http://schemas.openxmlformats.org/drawingml/2006/main" r:embed="R52fb7faa8c66492c"/>
+          <a:blip xmlns:r="http://schemas.openxmlformats.org/officeDocument/2006/relationships" xmlns:a="http://schemas.openxmlformats.org/drawingml/2006/main" r:embed="Refe0c40bcaad4bfa"/>
           <a:stretch xmlns:a="http://schemas.openxmlformats.org/drawingml/2006/main">
             <a:fillRect l="0" t="0" r="0" b="0"/>
           </a:stretch>
@@ -11503,7 +11503,7 @@
           <p:nvPr/>
         </p:nvPicPr>
         <p:blipFill>
-          <a:blip xmlns:r="http://schemas.openxmlformats.org/officeDocument/2006/relationships" xmlns:a="http://schemas.openxmlformats.org/drawingml/2006/main" r:embed="R7d45ea224ca94efb"/>
+          <a:blip xmlns:r="http://schemas.openxmlformats.org/officeDocument/2006/relationships" xmlns:a="http://schemas.openxmlformats.org/drawingml/2006/main" r:embed="Rfdd5a1f7c24f4814"/>
           <a:stretch xmlns:a="http://schemas.openxmlformats.org/drawingml/2006/main">
             <a:fillRect l="0" t="0" r="0" b="0"/>
           </a:stretch>
@@ -11527,7 +11527,7 @@
           <p:nvPr/>
         </p:nvPicPr>
         <p:blipFill>
-          <a:blip xmlns:r="http://schemas.openxmlformats.org/officeDocument/2006/relationships" xmlns:a="http://schemas.openxmlformats.org/drawingml/2006/main" r:embed="R52f0b7865f214f19"/>
+          <a:blip xmlns:r="http://schemas.openxmlformats.org/officeDocument/2006/relationships" xmlns:a="http://schemas.openxmlformats.org/drawingml/2006/main" r:embed="Re9046fc16474436d"/>
           <a:stretch xmlns:a="http://schemas.openxmlformats.org/drawingml/2006/main">
             <a:fillRect l="0" t="0" r="0" b="0"/>
           </a:stretch>
@@ -12449,7 +12449,7 @@
           <p:nvPr/>
         </p:nvPicPr>
         <p:blipFill>
-          <a:blip xmlns:r="http://schemas.openxmlformats.org/officeDocument/2006/relationships" xmlns:a="http://schemas.openxmlformats.org/drawingml/2006/main" r:embed="Ra2fa6f7895be4086"/>
+          <a:blip xmlns:r="http://schemas.openxmlformats.org/officeDocument/2006/relationships" xmlns:a="http://schemas.openxmlformats.org/drawingml/2006/main" r:embed="R6ad883c5048240e4"/>
           <a:stretch xmlns:a="http://schemas.openxmlformats.org/drawingml/2006/main">
             <a:fillRect l="0" t="0" r="0" b="0"/>
           </a:stretch>
@@ -12473,7 +12473,7 @@
           <p:nvPr/>
         </p:nvPicPr>
         <p:blipFill>
-          <a:blip xmlns:r="http://schemas.openxmlformats.org/officeDocument/2006/relationships" xmlns:a="http://schemas.openxmlformats.org/drawingml/2006/main" r:embed="Rbb87ab2dd9994f9f"/>
+          <a:blip xmlns:r="http://schemas.openxmlformats.org/officeDocument/2006/relationships" xmlns:a="http://schemas.openxmlformats.org/drawingml/2006/main" r:embed="R087e0ec017c94b5b"/>
           <a:stretch xmlns:a="http://schemas.openxmlformats.org/drawingml/2006/main">
             <a:fillRect l="0" t="0" r="0" b="0"/>
           </a:stretch>
@@ -12709,7 +12709,7 @@
           <p:nvPr/>
         </p:nvPicPr>
         <p:blipFill>
-          <a:blip xmlns:r="http://schemas.openxmlformats.org/officeDocument/2006/relationships" xmlns:a="http://schemas.openxmlformats.org/drawingml/2006/main" r:embed="Rc577e5a890164e2c"/>
+          <a:blip xmlns:r="http://schemas.openxmlformats.org/officeDocument/2006/relationships" xmlns:a="http://schemas.openxmlformats.org/drawingml/2006/main" r:embed="R42a8634a5dd54632"/>
           <a:stretch xmlns:a="http://schemas.openxmlformats.org/drawingml/2006/main">
             <a:fillRect l="0" t="0" r="0" b="0"/>
           </a:stretch>
@@ -12786,7 +12786,7 @@
           <p:nvPr/>
         </p:nvPicPr>
         <p:blipFill>
-          <a:blip xmlns:r="http://schemas.openxmlformats.org/officeDocument/2006/relationships" xmlns:a="http://schemas.openxmlformats.org/drawingml/2006/main" r:embed="R5def0938cdfc4f88"/>
+          <a:blip xmlns:r="http://schemas.openxmlformats.org/officeDocument/2006/relationships" xmlns:a="http://schemas.openxmlformats.org/drawingml/2006/main" r:embed="R3f475fe1bde34ba4"/>
           <a:stretch xmlns:a="http://schemas.openxmlformats.org/drawingml/2006/main">
             <a:fillRect l="0" t="0" r="0" b="0"/>
           </a:stretch>
@@ -12863,7 +12863,7 @@
           <p:nvPr/>
         </p:nvPicPr>
         <p:blipFill>
-          <a:blip xmlns:r="http://schemas.openxmlformats.org/officeDocument/2006/relationships" xmlns:a="http://schemas.openxmlformats.org/drawingml/2006/main" r:embed="R318b8830d5da4fd3"/>
+          <a:blip xmlns:r="http://schemas.openxmlformats.org/officeDocument/2006/relationships" xmlns:a="http://schemas.openxmlformats.org/drawingml/2006/main" r:embed="R89d4579755294630"/>
           <a:stretch xmlns:a="http://schemas.openxmlformats.org/drawingml/2006/main">
             <a:fillRect l="0" t="0" r="0" b="0"/>
           </a:stretch>
@@ -12940,7 +12940,7 @@
           <p:nvPr/>
         </p:nvPicPr>
         <p:blipFill>
-          <a:blip xmlns:r="http://schemas.openxmlformats.org/officeDocument/2006/relationships" xmlns:a="http://schemas.openxmlformats.org/drawingml/2006/main" r:embed="R4e5ee416ef264d9e"/>
+          <a:blip xmlns:r="http://schemas.openxmlformats.org/officeDocument/2006/relationships" xmlns:a="http://schemas.openxmlformats.org/drawingml/2006/main" r:embed="R785a3962b3ec41b3"/>
           <a:stretch xmlns:a="http://schemas.openxmlformats.org/drawingml/2006/main">
             <a:fillRect l="0" t="0" r="0" b="0"/>
           </a:stretch>
@@ -13017,7 +13017,7 @@
           <p:nvPr/>
         </p:nvPicPr>
         <p:blipFill>
-          <a:blip xmlns:r="http://schemas.openxmlformats.org/officeDocument/2006/relationships" xmlns:a="http://schemas.openxmlformats.org/drawingml/2006/main" r:embed="R692332a429434f2c"/>
+          <a:blip xmlns:r="http://schemas.openxmlformats.org/officeDocument/2006/relationships" xmlns:a="http://schemas.openxmlformats.org/drawingml/2006/main" r:embed="Rcdfa0b44d5d84e1e"/>
           <a:stretch xmlns:a="http://schemas.openxmlformats.org/drawingml/2006/main">
             <a:fillRect l="0" t="0" r="0" b="0"/>
           </a:stretch>
@@ -13094,7 +13094,7 @@
           <p:nvPr/>
         </p:nvPicPr>
         <p:blipFill>
-          <a:blip xmlns:r="http://schemas.openxmlformats.org/officeDocument/2006/relationships" xmlns:a="http://schemas.openxmlformats.org/drawingml/2006/main" r:embed="Rca2ba88189404447"/>
+          <a:blip xmlns:r="http://schemas.openxmlformats.org/officeDocument/2006/relationships" xmlns:a="http://schemas.openxmlformats.org/drawingml/2006/main" r:embed="R6f10652ca6e74870"/>
           <a:stretch xmlns:a="http://schemas.openxmlformats.org/drawingml/2006/main">
             <a:fillRect l="0" t="0" r="0" b="0"/>
           </a:stretch>
@@ -13171,7 +13171,7 @@
           <p:nvPr/>
         </p:nvPicPr>
         <p:blipFill>
-          <a:blip xmlns:r="http://schemas.openxmlformats.org/officeDocument/2006/relationships" xmlns:a="http://schemas.openxmlformats.org/drawingml/2006/main" r:embed="Rfbffdadb0a754ce6"/>
+          <a:blip xmlns:r="http://schemas.openxmlformats.org/officeDocument/2006/relationships" xmlns:a="http://schemas.openxmlformats.org/drawingml/2006/main" r:embed="Raf03e691f4084548"/>
           <a:stretch xmlns:a="http://schemas.openxmlformats.org/drawingml/2006/main">
             <a:fillRect l="0" t="0" r="0" b="0"/>
           </a:stretch>
@@ -13461,7 +13461,7 @@
           <p:nvPr/>
         </p:nvPicPr>
         <p:blipFill>
-          <a:blip xmlns:r="http://schemas.openxmlformats.org/officeDocument/2006/relationships" xmlns:a="http://schemas.openxmlformats.org/drawingml/2006/main" r:embed="Rd97ac0c8f06142b1"/>
+          <a:blip xmlns:r="http://schemas.openxmlformats.org/officeDocument/2006/relationships" xmlns:a="http://schemas.openxmlformats.org/drawingml/2006/main" r:embed="R1c6f1c285bde4649"/>
           <a:stretch xmlns:a="http://schemas.openxmlformats.org/drawingml/2006/main">
             <a:fillRect l="0" t="0" r="0" b="0"/>
           </a:stretch>
@@ -13644,7 +13644,7 @@
           <p:nvPr/>
         </p:nvPicPr>
         <p:blipFill>
-          <a:blip xmlns:r="http://schemas.openxmlformats.org/officeDocument/2006/relationships" xmlns:a="http://schemas.openxmlformats.org/drawingml/2006/main" r:embed="R7b9b7e7c2af540bd"/>
+          <a:blip xmlns:r="http://schemas.openxmlformats.org/officeDocument/2006/relationships" xmlns:a="http://schemas.openxmlformats.org/drawingml/2006/main" r:embed="R5f1809e7967040eb"/>
           <a:stretch xmlns:a="http://schemas.openxmlformats.org/drawingml/2006/main">
             <a:fillRect l="0" t="0" r="0" b="0"/>
           </a:stretch>
@@ -13668,7 +13668,7 @@
           <p:nvPr/>
         </p:nvPicPr>
         <p:blipFill>
-          <a:blip xmlns:r="http://schemas.openxmlformats.org/officeDocument/2006/relationships" xmlns:a="http://schemas.openxmlformats.org/drawingml/2006/main" r:embed="R5635507e934344c4"/>
+          <a:blip xmlns:r="http://schemas.openxmlformats.org/officeDocument/2006/relationships" xmlns:a="http://schemas.openxmlformats.org/drawingml/2006/main" r:embed="Ra93030bdbca64f7e"/>
           <a:stretch xmlns:a="http://schemas.openxmlformats.org/drawingml/2006/main">
             <a:fillRect l="0" t="0" r="0" b="0"/>
           </a:stretch>
@@ -14591,7 +14591,7 @@
           <p:nvPr/>
         </p:nvPicPr>
         <p:blipFill>
-          <a:blip xmlns:r="http://schemas.openxmlformats.org/officeDocument/2006/relationships" xmlns:a="http://schemas.openxmlformats.org/drawingml/2006/main" r:embed="R7e469e0927e0444f"/>
+          <a:blip xmlns:r="http://schemas.openxmlformats.org/officeDocument/2006/relationships" xmlns:a="http://schemas.openxmlformats.org/drawingml/2006/main" r:embed="Re6f6a52af5ad4499"/>
           <a:stretch xmlns:a="http://schemas.openxmlformats.org/drawingml/2006/main">
             <a:fillRect l="0" t="0" r="0" b="0"/>
           </a:stretch>
@@ -14615,7 +14615,7 @@
           <p:nvPr/>
         </p:nvPicPr>
         <p:blipFill>
-          <a:blip xmlns:r="http://schemas.openxmlformats.org/officeDocument/2006/relationships" xmlns:a="http://schemas.openxmlformats.org/drawingml/2006/main" r:embed="Rf0f32c04cc234695"/>
+          <a:blip xmlns:r="http://schemas.openxmlformats.org/officeDocument/2006/relationships" xmlns:a="http://schemas.openxmlformats.org/drawingml/2006/main" r:embed="Rc0984eae60354fed"/>
           <a:stretch xmlns:a="http://schemas.openxmlformats.org/drawingml/2006/main">
             <a:fillRect l="0" t="0" r="0" b="0"/>
           </a:stretch>
@@ -14851,7 +14851,7 @@
           <p:nvPr/>
         </p:nvPicPr>
         <p:blipFill>
-          <a:blip xmlns:r="http://schemas.openxmlformats.org/officeDocument/2006/relationships" xmlns:a="http://schemas.openxmlformats.org/drawingml/2006/main" r:embed="R689e5e5ed5904427"/>
+          <a:blip xmlns:r="http://schemas.openxmlformats.org/officeDocument/2006/relationships" xmlns:a="http://schemas.openxmlformats.org/drawingml/2006/main" r:embed="R03455c8015f84986"/>
           <a:stretch xmlns:a="http://schemas.openxmlformats.org/drawingml/2006/main">
             <a:fillRect l="0" t="0" r="0" b="0"/>
           </a:stretch>
@@ -14928,7 +14928,7 @@
           <p:nvPr/>
         </p:nvPicPr>
         <p:blipFill>
-          <a:blip xmlns:r="http://schemas.openxmlformats.org/officeDocument/2006/relationships" xmlns:a="http://schemas.openxmlformats.org/drawingml/2006/main" r:embed="R3f96794ba36943fb"/>
+          <a:blip xmlns:r="http://schemas.openxmlformats.org/officeDocument/2006/relationships" xmlns:a="http://schemas.openxmlformats.org/drawingml/2006/main" r:embed="Ra468531cb1a5466b"/>
           <a:stretch xmlns:a="http://schemas.openxmlformats.org/drawingml/2006/main">
             <a:fillRect l="0" t="0" r="0" b="0"/>
           </a:stretch>
@@ -15005,7 +15005,7 @@
           <p:nvPr/>
         </p:nvPicPr>
         <p:blipFill>
-          <a:blip xmlns:r="http://schemas.openxmlformats.org/officeDocument/2006/relationships" xmlns:a="http://schemas.openxmlformats.org/drawingml/2006/main" r:embed="Ra04d46a1e719458b"/>
+          <a:blip xmlns:r="http://schemas.openxmlformats.org/officeDocument/2006/relationships" xmlns:a="http://schemas.openxmlformats.org/drawingml/2006/main" r:embed="Rd39bb4cf653042b7"/>
           <a:stretch xmlns:a="http://schemas.openxmlformats.org/drawingml/2006/main">
             <a:fillRect l="0" t="0" r="0" b="0"/>
           </a:stretch>
@@ -15082,7 +15082,7 @@
           <p:nvPr/>
         </p:nvPicPr>
         <p:blipFill>
-          <a:blip xmlns:r="http://schemas.openxmlformats.org/officeDocument/2006/relationships" xmlns:a="http://schemas.openxmlformats.org/drawingml/2006/main" r:embed="R5794132f5b30452b"/>
+          <a:blip xmlns:r="http://schemas.openxmlformats.org/officeDocument/2006/relationships" xmlns:a="http://schemas.openxmlformats.org/drawingml/2006/main" r:embed="R8ca2f490254341b3"/>
           <a:stretch xmlns:a="http://schemas.openxmlformats.org/drawingml/2006/main">
             <a:fillRect l="0" t="0" r="0" b="0"/>
           </a:stretch>
@@ -15159,7 +15159,7 @@
           <p:nvPr/>
         </p:nvPicPr>
         <p:blipFill>
-          <a:blip xmlns:r="http://schemas.openxmlformats.org/officeDocument/2006/relationships" xmlns:a="http://schemas.openxmlformats.org/drawingml/2006/main" r:embed="R457696ed69c24bf8"/>
+          <a:blip xmlns:r="http://schemas.openxmlformats.org/officeDocument/2006/relationships" xmlns:a="http://schemas.openxmlformats.org/drawingml/2006/main" r:embed="R8ccb1f0676e54205"/>
           <a:stretch xmlns:a="http://schemas.openxmlformats.org/drawingml/2006/main">
             <a:fillRect l="0" t="0" r="0" b="0"/>
           </a:stretch>
@@ -15236,7 +15236,7 @@
           <p:nvPr/>
         </p:nvPicPr>
         <p:blipFill>
-          <a:blip xmlns:r="http://schemas.openxmlformats.org/officeDocument/2006/relationships" xmlns:a="http://schemas.openxmlformats.org/drawingml/2006/main" r:embed="Rbd65cdcf0e7b4f6d"/>
+          <a:blip xmlns:r="http://schemas.openxmlformats.org/officeDocument/2006/relationships" xmlns:a="http://schemas.openxmlformats.org/drawingml/2006/main" r:embed="R054aadb3c6804c86"/>
           <a:stretch xmlns:a="http://schemas.openxmlformats.org/drawingml/2006/main">
             <a:fillRect l="0" t="0" r="0" b="0"/>
           </a:stretch>
@@ -15313,7 +15313,7 @@
           <p:nvPr/>
         </p:nvPicPr>
         <p:blipFill>
-          <a:blip xmlns:r="http://schemas.openxmlformats.org/officeDocument/2006/relationships" xmlns:a="http://schemas.openxmlformats.org/drawingml/2006/main" r:embed="R769697caa7ff4b39"/>
+          <a:blip xmlns:r="http://schemas.openxmlformats.org/officeDocument/2006/relationships" xmlns:a="http://schemas.openxmlformats.org/drawingml/2006/main" r:embed="R538fc421d2b24cb9"/>
           <a:stretch xmlns:a="http://schemas.openxmlformats.org/drawingml/2006/main">
             <a:fillRect l="0" t="0" r="0" b="0"/>
           </a:stretch>
@@ -15603,7 +15603,7 @@
           <p:nvPr/>
         </p:nvPicPr>
         <p:blipFill>
-          <a:blip xmlns:r="http://schemas.openxmlformats.org/officeDocument/2006/relationships" xmlns:a="http://schemas.openxmlformats.org/drawingml/2006/main" r:embed="Re81ed83b0be24546"/>
+          <a:blip xmlns:r="http://schemas.openxmlformats.org/officeDocument/2006/relationships" xmlns:a="http://schemas.openxmlformats.org/drawingml/2006/main" r:embed="R1d0e3efd973f4b8b"/>
           <a:stretch xmlns:a="http://schemas.openxmlformats.org/drawingml/2006/main">
             <a:fillRect l="0" t="0" r="0" b="0"/>
           </a:stretch>
@@ -15786,7 +15786,7 @@
           <p:nvPr/>
         </p:nvPicPr>
         <p:blipFill>
-          <a:blip xmlns:r="http://schemas.openxmlformats.org/officeDocument/2006/relationships" xmlns:a="http://schemas.openxmlformats.org/drawingml/2006/main" r:embed="R84a9f19e086d433e"/>
+          <a:blip xmlns:r="http://schemas.openxmlformats.org/officeDocument/2006/relationships" xmlns:a="http://schemas.openxmlformats.org/drawingml/2006/main" r:embed="R9f39f03dabfc4dbb"/>
           <a:stretch xmlns:a="http://schemas.openxmlformats.org/drawingml/2006/main">
             <a:fillRect l="0" t="0" r="0" b="0"/>
           </a:stretch>
@@ -15810,7 +15810,7 @@
           <p:nvPr/>
         </p:nvPicPr>
         <p:blipFill>
-          <a:blip xmlns:r="http://schemas.openxmlformats.org/officeDocument/2006/relationships" xmlns:a="http://schemas.openxmlformats.org/drawingml/2006/main" r:embed="R9144c25c0ab44684"/>
+          <a:blip xmlns:r="http://schemas.openxmlformats.org/officeDocument/2006/relationships" xmlns:a="http://schemas.openxmlformats.org/drawingml/2006/main" r:embed="Rba584569a98142cb"/>
           <a:stretch xmlns:a="http://schemas.openxmlformats.org/drawingml/2006/main">
             <a:fillRect l="0" t="0" r="0" b="0"/>
           </a:stretch>
@@ -16046,7 +16046,7 @@
           <p:nvPr/>
         </p:nvPicPr>
         <p:blipFill>
-          <a:blip xmlns:r="http://schemas.openxmlformats.org/officeDocument/2006/relationships" xmlns:a="http://schemas.openxmlformats.org/drawingml/2006/main" r:embed="Rff479db294e340f5"/>
+          <a:blip xmlns:r="http://schemas.openxmlformats.org/officeDocument/2006/relationships" xmlns:a="http://schemas.openxmlformats.org/drawingml/2006/main" r:embed="R454373c473654487"/>
           <a:stretch xmlns:a="http://schemas.openxmlformats.org/drawingml/2006/main">
             <a:fillRect l="0" t="0" r="0" b="0"/>
           </a:stretch>
@@ -16123,7 +16123,7 @@
           <p:nvPr/>
         </p:nvPicPr>
         <p:blipFill>
-          <a:blip xmlns:r="http://schemas.openxmlformats.org/officeDocument/2006/relationships" xmlns:a="http://schemas.openxmlformats.org/drawingml/2006/main" r:embed="R563a58458bf14c7e"/>
+          <a:blip xmlns:r="http://schemas.openxmlformats.org/officeDocument/2006/relationships" xmlns:a="http://schemas.openxmlformats.org/drawingml/2006/main" r:embed="Raabece6fd8204ea7"/>
           <a:stretch xmlns:a="http://schemas.openxmlformats.org/drawingml/2006/main">
             <a:fillRect l="0" t="0" r="0" b="0"/>
           </a:stretch>
@@ -16200,7 +16200,7 @@
           <p:nvPr/>
         </p:nvPicPr>
         <p:blipFill>
-          <a:blip xmlns:r="http://schemas.openxmlformats.org/officeDocument/2006/relationships" xmlns:a="http://schemas.openxmlformats.org/drawingml/2006/main" r:embed="R355ad56285434817"/>
+          <a:blip xmlns:r="http://schemas.openxmlformats.org/officeDocument/2006/relationships" xmlns:a="http://schemas.openxmlformats.org/drawingml/2006/main" r:embed="R85212dd210be41ae"/>
           <a:stretch xmlns:a="http://schemas.openxmlformats.org/drawingml/2006/main">
             <a:fillRect l="0" t="0" r="0" b="0"/>
           </a:stretch>
@@ -16277,7 +16277,7 @@
           <p:nvPr/>
         </p:nvPicPr>
         <p:blipFill>
-          <a:blip xmlns:r="http://schemas.openxmlformats.org/officeDocument/2006/relationships" xmlns:a="http://schemas.openxmlformats.org/drawingml/2006/main" r:embed="R9b169ca397b24385"/>
+          <a:blip xmlns:r="http://schemas.openxmlformats.org/officeDocument/2006/relationships" xmlns:a="http://schemas.openxmlformats.org/drawingml/2006/main" r:embed="Rcc856a26d33f4330"/>
           <a:stretch xmlns:a="http://schemas.openxmlformats.org/drawingml/2006/main">
             <a:fillRect l="0" t="0" r="0" b="0"/>
           </a:stretch>
@@ -16354,7 +16354,7 @@
           <p:nvPr/>
         </p:nvPicPr>
         <p:blipFill>
-          <a:blip xmlns:r="http://schemas.openxmlformats.org/officeDocument/2006/relationships" xmlns:a="http://schemas.openxmlformats.org/drawingml/2006/main" r:embed="R9e2711f010b24058"/>
+          <a:blip xmlns:r="http://schemas.openxmlformats.org/officeDocument/2006/relationships" xmlns:a="http://schemas.openxmlformats.org/drawingml/2006/main" r:embed="R223fc577898649e0"/>
           <a:stretch xmlns:a="http://schemas.openxmlformats.org/drawingml/2006/main">
             <a:fillRect l="0" t="0" r="0" b="0"/>
           </a:stretch>
@@ -16431,7 +16431,7 @@
           <p:nvPr/>
         </p:nvPicPr>
         <p:blipFill>
-          <a:blip xmlns:r="http://schemas.openxmlformats.org/officeDocument/2006/relationships" xmlns:a="http://schemas.openxmlformats.org/drawingml/2006/main" r:embed="R3b1ed4ff28504b98"/>
+          <a:blip xmlns:r="http://schemas.openxmlformats.org/officeDocument/2006/relationships" xmlns:a="http://schemas.openxmlformats.org/drawingml/2006/main" r:embed="R4aeeef49949140fe"/>
           <a:stretch xmlns:a="http://schemas.openxmlformats.org/drawingml/2006/main">
             <a:fillRect l="0" t="0" r="0" b="0"/>
           </a:stretch>
@@ -16508,7 +16508,7 @@
           <p:nvPr/>
         </p:nvPicPr>
         <p:blipFill>
-          <a:blip xmlns:r="http://schemas.openxmlformats.org/officeDocument/2006/relationships" xmlns:a="http://schemas.openxmlformats.org/drawingml/2006/main" r:embed="Rb016592317a74a69"/>
+          <a:blip xmlns:r="http://schemas.openxmlformats.org/officeDocument/2006/relationships" xmlns:a="http://schemas.openxmlformats.org/drawingml/2006/main" r:embed="R2196bc66a9f840d1"/>
           <a:stretch xmlns:a="http://schemas.openxmlformats.org/drawingml/2006/main">
             <a:fillRect l="0" t="0" r="0" b="0"/>
           </a:stretch>
@@ -16798,7 +16798,7 @@
           <p:nvPr/>
         </p:nvPicPr>
         <p:blipFill>
-          <a:blip xmlns:r="http://schemas.openxmlformats.org/officeDocument/2006/relationships" xmlns:a="http://schemas.openxmlformats.org/drawingml/2006/main" r:embed="R30d8fbf10e9f462c"/>
+          <a:blip xmlns:r="http://schemas.openxmlformats.org/officeDocument/2006/relationships" xmlns:a="http://schemas.openxmlformats.org/drawingml/2006/main" r:embed="R29226e97da584e3d"/>
           <a:stretch xmlns:a="http://schemas.openxmlformats.org/drawingml/2006/main">
             <a:fillRect l="0" t="0" r="0" b="0"/>
           </a:stretch>

</xml_diff>